<commit_message>
Finalize onboarding deck v21 + sync across all artifacts
onboarding-deck.pptx (21 slides — final):
- Slide 20: Quick Reference fully rebuilt with phase-color stripes
  and label text per phase (01 green → 06 teal, gray for cross-phase/tools)
  11 skills + 4 tools + Figma File + GitHub in clean 9-row x 2-col layout
- Slide 21: Closing updated with Live Site, Figma Template, GitHub Repo
  links evenly spaced, repo URL → Agentic-Product-Design-Framework
- All other updates from previous session retained:
  11 skill files, AI-powered tools section, new tool names

Artifact sync (18 → 21 slides, old repo URL → Agentic):
- artifacts/design-process-system.jsx: updated description + repo URL
- artifacts/design-tokens-system.jsx: updated description + repo URL
- web/src/DesignProcessSystem.jsx: updated description
</commit_message>
<xml_diff>
--- a/artifacts/onboarding-deck.pptx
+++ b/artifacts/onboarding-deck.pptx
@@ -2276,101 +2276,13 @@
       </p:grpSpPr>
       <p:sp>
         <p:nvSpPr>
-          <p:cNvPr id="2" name="Text 0"/>
-          <p:cNvSpPr/>
-          <p:nvPr/>
-        </p:nvSpPr>
-        <p:spPr>
-          <a:xfrm>
-            <a:off x="513080" y="1280160"/>
-            <a:ext cx="6858000" cy="1920240"/>
-          </a:xfrm>
-          <a:prstGeom prst="rect">
-            <a:avLst/>
-          </a:prstGeom>
-          <a:noFill/>
-          <a:ln/>
-        </p:spPr>
-        <p:txBody>
-          <a:bodyPr wrap="square" rtlCol="0" anchor="ctr"/>
-          <a:lstStyle/>
-          <a:p>
-            <a:pPr marL="0" indent="0">
-              <a:buNone/>
-            </a:pPr>
-            <a:r>
-              <a:rPr lang="en-US" sz="6000" b="1" dirty="0">
-                <a:solidFill>
-                  <a:srgbClr val="FFFFFF"/>
-                </a:solidFill>
-                <a:latin typeface="Calibri" pitchFamily="34" charset="0"/>
-                <a:ea typeface="Calibri" pitchFamily="34" charset="-122"/>
-                <a:cs typeface="Calibri" pitchFamily="34" charset="-120"/>
-              </a:rPr>
-              <a:t>AI x UX</a:t>
-            </a:r>
-            <a:endParaRPr lang="en-US" sz="6000" dirty="0"/>
-          </a:p>
-          <a:p>
-            <a:pPr marL="0" indent="0">
-              <a:buNone/>
-            </a:pPr>
-            <a:r>
-              <a:rPr lang="en-US" sz="6000" b="1" dirty="0">
-                <a:solidFill>
-                  <a:srgbClr val="FFFFFF"/>
-                </a:solidFill>
-                <a:latin typeface="Calibri" pitchFamily="34" charset="0"/>
-                <a:ea typeface="Calibri" pitchFamily="34" charset="-122"/>
-                <a:cs typeface="Calibri" pitchFamily="34" charset="-120"/>
-              </a:rPr>
-              <a:t>Design Framework</a:t>
-            </a:r>
-            <a:endParaRPr lang="en-US" sz="6000" dirty="0"/>
-          </a:p>
-        </p:txBody>
-      </p:sp>
-      <p:sp>
-        <p:nvSpPr>
-          <p:cNvPr id="3" name="Shape 1"/>
-          <p:cNvSpPr/>
-          <p:nvPr/>
-        </p:nvSpPr>
-        <p:spPr>
-          <a:xfrm>
-            <a:off x="640080" y="3364992"/>
-            <a:ext cx="1097280" cy="45720"/>
-          </a:xfrm>
-          <a:prstGeom prst="rect">
-            <a:avLst/>
-          </a:prstGeom>
-          <a:solidFill>
-            <a:srgbClr val="22C55E"/>
-          </a:solidFill>
-          <a:ln w="12700">
-            <a:solidFill>
-              <a:srgbClr val="22C55E"/>
-            </a:solidFill>
-            <a:prstDash val="solid"/>
-          </a:ln>
-        </p:spPr>
-        <p:txBody>
-          <a:bodyPr/>
-          <a:lstStyle/>
-          <a:p>
-            <a:endParaRPr lang="en-US"/>
-          </a:p>
-        </p:txBody>
-      </p:sp>
-      <p:sp>
-        <p:nvSpPr>
           <p:cNvPr id="4" name="Text 2"/>
           <p:cNvSpPr/>
           <p:nvPr/>
         </p:nvSpPr>
         <p:spPr>
           <a:xfrm>
-            <a:off x="551180" y="3511296"/>
+            <a:off x="551180" y="2638564"/>
             <a:ext cx="5943600" cy="685800"/>
           </a:xfrm>
           <a:prstGeom prst="rect">
@@ -2652,7 +2564,7 @@
                 <a:ea typeface="Calibri" pitchFamily="34" charset="-122"/>
                 <a:cs typeface="Calibri" pitchFamily="34" charset="-120"/>
               </a:rPr>
-              <a:t>9 Skill Files</a:t>
+              <a:t>11 Skill Files</a:t>
             </a:r>
             <a:endParaRPr lang="en-US" sz="1400" dirty="0"/>
           </a:p>
@@ -2733,36 +2645,6 @@
               <a:t>High throughout</a:t>
             </a:r>
             <a:endParaRPr lang="en-US" sz="1400" dirty="0"/>
-          </a:p>
-        </p:txBody>
-      </p:sp>
-      <p:sp>
-        <p:nvSpPr>
-          <p:cNvPr id="13" name="Shape 11"/>
-          <p:cNvSpPr/>
-          <p:nvPr/>
-        </p:nvSpPr>
-        <p:spPr>
-          <a:xfrm>
-            <a:off x="640080" y="5577840"/>
-            <a:ext cx="10881360" cy="0"/>
-          </a:xfrm>
-          <a:prstGeom prst="line">
-            <a:avLst/>
-          </a:prstGeom>
-          <a:noFill/>
-          <a:ln w="6350">
-            <a:solidFill>
-              <a:srgbClr val="334155"/>
-            </a:solidFill>
-            <a:prstDash val="solid"/>
-          </a:ln>
-        </p:spPr>
-        <p:txBody>
-          <a:bodyPr/>
-          <a:lstStyle/>
-          <a:p>
-            <a:endParaRPr lang="en-US"/>
           </a:p>
         </p:txBody>
       </p:sp>
@@ -3318,6 +3200,104 @@
               <a:t>v1.0 — Duplicate the Figma template for each new project</a:t>
             </a:r>
             <a:endParaRPr lang="en-US" sz="900" dirty="0"/>
+          </a:p>
+        </p:txBody>
+      </p:sp>
+      <p:sp>
+        <p:nvSpPr>
+          <p:cNvPr id="27" name="Text 0">
+            <a:extLst>
+              <a:ext uri="{FF2B5EF4-FFF2-40B4-BE49-F238E27FC236}">
+                <a16:creationId xmlns:a16="http://schemas.microsoft.com/office/drawing/2014/main" id="{04332FF0-9213-0424-5B31-D8F994501510}"/>
+              </a:ext>
+            </a:extLst>
+          </p:cNvPr>
+          <p:cNvSpPr/>
+          <p:nvPr/>
+        </p:nvSpPr>
+        <p:spPr>
+          <a:xfrm>
+            <a:off x="513080" y="403376"/>
+            <a:ext cx="7315200" cy="1874520"/>
+          </a:xfrm>
+          <a:prstGeom prst="rect">
+            <a:avLst/>
+          </a:prstGeom>
+          <a:noFill/>
+          <a:ln/>
+        </p:spPr>
+        <p:txBody>
+          <a:bodyPr wrap="square" rtlCol="0" anchor="ctr"/>
+          <a:lstStyle/>
+          <a:p>
+            <a:pPr marL="0" indent="0">
+              <a:buNone/>
+            </a:pPr>
+            <a:r>
+              <a:rPr lang="en-US" sz="5600" b="1" dirty="0">
+                <a:solidFill>
+                  <a:srgbClr val="FFFFFF"/>
+                </a:solidFill>
+                <a:latin typeface="Calibri" pitchFamily="34" charset="0"/>
+                <a:ea typeface="Calibri" pitchFamily="34" charset="-122"/>
+                <a:cs typeface="Calibri" pitchFamily="34" charset="-120"/>
+              </a:rPr>
+              <a:t>Agentic Product</a:t>
+            </a:r>
+            <a:r>
+              <a:rPr lang="en-US" sz="5600" dirty="0"/>
+              <a:t> </a:t>
+            </a:r>
+            <a:r>
+              <a:rPr lang="en-US" sz="5600" b="1" dirty="0">
+                <a:solidFill>
+                  <a:srgbClr val="FFFFFF"/>
+                </a:solidFill>
+                <a:latin typeface="Calibri" pitchFamily="34" charset="0"/>
+                <a:ea typeface="Calibri" pitchFamily="34" charset="-122"/>
+                <a:cs typeface="Calibri" pitchFamily="34" charset="-120"/>
+              </a:rPr>
+              <a:t>Design Framework</a:t>
+            </a:r>
+            <a:endParaRPr lang="en-US" sz="5600" dirty="0"/>
+          </a:p>
+        </p:txBody>
+      </p:sp>
+      <p:sp>
+        <p:nvSpPr>
+          <p:cNvPr id="28" name="Shape 1">
+            <a:extLst>
+              <a:ext uri="{FF2B5EF4-FFF2-40B4-BE49-F238E27FC236}">
+                <a16:creationId xmlns:a16="http://schemas.microsoft.com/office/drawing/2014/main" id="{26FEB608-F140-D9DA-E84B-9021EE55EF31}"/>
+              </a:ext>
+            </a:extLst>
+          </p:cNvPr>
+          <p:cNvSpPr/>
+          <p:nvPr/>
+        </p:nvSpPr>
+        <p:spPr>
+          <a:xfrm>
+            <a:off x="640080" y="2387624"/>
+            <a:ext cx="1097280" cy="45720"/>
+          </a:xfrm>
+          <a:prstGeom prst="rect">
+            <a:avLst/>
+          </a:prstGeom>
+          <a:solidFill>
+            <a:srgbClr val="22C55E"/>
+          </a:solidFill>
+          <a:ln w="12700">
+            <a:solidFill>
+              <a:srgbClr val="22C55E"/>
+            </a:solidFill>
+            <a:prstDash val="solid"/>
+          </a:ln>
+        </p:spPr>
+        <p:txBody>
+          <a:bodyPr/>
+          <a:lstStyle/>
+          <a:p>
+            <a:endParaRPr lang="en-US"/>
           </a:p>
         </p:txBody>
       </p:sp>
@@ -3463,7 +3443,7 @@
                 <a:ea typeface="Calibri" pitchFamily="34" charset="-122"/>
                 <a:cs typeface="Calibri" pitchFamily="34" charset="-120"/>
               </a:rPr>
-              <a:t>Nine structured skill files</a:t>
+              <a:t>Eleven structured skill files</a:t>
             </a:r>
             <a:endParaRPr lang="en-US" sz="3200" dirty="0"/>
           </a:p>
@@ -7527,7 +7507,7 @@
                 <a:ea typeface="Calibri" pitchFamily="34" charset="-122"/>
                 <a:cs typeface="Calibri" pitchFamily="34" charset="-120"/>
               </a:rPr>
-              <a:t>INTERACTIVE ARTIFACTS</a:t>
+              <a:t>AI-POWERED DESIGN TOOLS</a:t>
             </a:r>
             <a:endParaRPr lang="en-US" sz="900" dirty="0">
               <a:solidFill>
@@ -7570,7 +7550,7 @@
                 <a:ea typeface="Calibri" pitchFamily="34" charset="-122"/>
                 <a:cs typeface="Calibri" pitchFamily="34" charset="-120"/>
               </a:rPr>
-              <a:t>Four interactive React artifacts</a:t>
+              <a:t>Four AI-powered design tools</a:t>
             </a:r>
             <a:endParaRPr lang="en-US" sz="3200" dirty="0"/>
           </a:p>
@@ -7609,7 +7589,7 @@
                 <a:ea typeface="Calibri" pitchFamily="34" charset="-122"/>
                 <a:cs typeface="Calibri" pitchFamily="34" charset="-120"/>
               </a:rPr>
-              <a:t>Live tools you use directly in Claude — no setup required.</a:t>
+              <a:t>Live on the web at quinrobinson.github.io/Agentic-Product-Design-Framework</a:t>
             </a:r>
             <a:endParaRPr lang="en-US" sz="1400" dirty="0"/>
           </a:p>
@@ -7973,7 +7953,7 @@
                 <a:ea typeface="Calibri" pitchFamily="34" charset="-122"/>
                 <a:cs typeface="Calibri" pitchFamily="34" charset="-120"/>
               </a:rPr>
-              <a:t>design-tokens-system.jsx</a:t>
+              <a:t>AIBriefGenerator.jsx</a:t>
             </a:r>
             <a:endParaRPr lang="en-US" sz="900" dirty="0">
               <a:solidFill>
@@ -8016,7 +7996,7 @@
                 <a:ea typeface="Calibri" pitchFamily="34" charset="-122"/>
                 <a:cs typeface="Calibri" pitchFamily="34" charset="-120"/>
               </a:rPr>
-              <a:t>Design Tokens System</a:t>
+              <a:t>AI Brief Generator</a:t>
             </a:r>
             <a:endParaRPr lang="en-US" sz="1500" dirty="0"/>
           </a:p>
@@ -8058,7 +8038,7 @@
                 <a:ea typeface="Calibri" pitchFamily="34" charset="-122"/>
                 <a:cs typeface="Calibri" pitchFamily="34" charset="-120"/>
               </a:rPr>
-              <a:t>Universal starter design system with tunable tokens, live component previews, presets, and AI-powered export.</a:t>
+              <a:t>3-step form that turns project context into a ready-to-paste Claude brief. Replaces the blank-page start.</a:t>
             </a:r>
             <a:endParaRPr lang="en-US" sz="1100" dirty="0"/>
           </a:p>
@@ -8236,7 +8216,7 @@
                 <a:ea typeface="Calibri" pitchFamily="34" charset="-122"/>
                 <a:cs typeface="Calibri" pitchFamily="34" charset="-120"/>
               </a:rPr>
-              <a:t>design-system-checklist.jsx</a:t>
+              <a:t>BrandStyleBuilder.jsx</a:t>
             </a:r>
             <a:endParaRPr lang="en-US" sz="900" dirty="0">
               <a:solidFill>
@@ -8279,7 +8259,7 @@
                 <a:ea typeface="Calibri" pitchFamily="34" charset="-122"/>
                 <a:cs typeface="Calibri" pitchFamily="34" charset="-120"/>
               </a:rPr>
-              <a:t>Design System Checklist</a:t>
+              <a:t>Brand Style Builder</a:t>
             </a:r>
             <a:endParaRPr lang="en-US" sz="1500" dirty="0"/>
           </a:p>
@@ -8321,7 +8301,7 @@
                 <a:ea typeface="Calibri" pitchFamily="34" charset="-122"/>
                 <a:cs typeface="Calibri" pitchFamily="34" charset="-120"/>
               </a:rPr>
-              <a:t>Comprehensive audit checklist from M3, Atlassian, IBM Carbon, and Apple HIG — with Figma-ready prompts.</a:t>
+              <a:t>Build a client's visual identity in minutes — tunable tokens, live previews, presets, and AI export.</a:t>
             </a:r>
             <a:endParaRPr lang="en-US" sz="1100" dirty="0"/>
           </a:p>
@@ -8499,7 +8479,7 @@
                 <a:ea typeface="Calibri" pitchFamily="34" charset="-122"/>
                 <a:cs typeface="Calibri" pitchFamily="34" charset="-120"/>
               </a:rPr>
-              <a:t>m3-token-reference.jsx</a:t>
+              <a:t>DesignSystemAudit.jsx</a:t>
             </a:r>
             <a:endParaRPr lang="en-US" sz="900" dirty="0">
               <a:solidFill>
@@ -8542,7 +8522,7 @@
                 <a:ea typeface="Calibri" pitchFamily="34" charset="-122"/>
                 <a:cs typeface="Calibri" pitchFamily="34" charset="-120"/>
               </a:rPr>
-              <a:t>M3 Token Reference</a:t>
+              <a:t>Design System Audit</a:t>
             </a:r>
             <a:endParaRPr lang="en-US" sz="1500" dirty="0"/>
           </a:p>
@@ -8584,7 +8564,7 @@
                 <a:ea typeface="Calibri" pitchFamily="34" charset="-122"/>
                 <a:cs typeface="Calibri" pitchFamily="34" charset="-120"/>
               </a:rPr>
-              <a:t>Interactive M3 token docs for Button, Card, Text Field, and Nav Bar — color roles, shape, type, and spacing.</a:t>
+              <a:t>Comprehensive audit checklist from M3, Atlassian, Carbon, and Apple HIG — with Figma-ready prompts.</a:t>
             </a:r>
             <a:endParaRPr lang="en-US" sz="1100" dirty="0"/>
           </a:p>
@@ -16511,7 +16491,7 @@
                 <a:ea typeface="Calibri" pitchFamily="34" charset="-122"/>
                 <a:cs typeface="Calibri" pitchFamily="34" charset="-120"/>
               </a:rPr>
-              <a:t>9 skill files covering every design phase — from discovery through delivery.</a:t>
+              <a:t>11 skill files covering every design phase — from discovery through delivery.</a:t>
             </a:r>
             <a:endParaRPr lang="en-US" sz="1200" dirty="0"/>
           </a:p>
@@ -16841,7 +16821,7 @@
                 <a:ea typeface="Calibri" pitchFamily="34" charset="-122"/>
                 <a:cs typeface="Calibri" pitchFamily="34" charset="-120"/>
               </a:rPr>
-              <a:t>9</a:t>
+              <a:t>11</a:t>
             </a:r>
             <a:endParaRPr lang="en-US" sz="4800" dirty="0">
               <a:solidFill>
@@ -17063,7 +17043,7 @@
                 <a:ea typeface="Calibri" pitchFamily="34" charset="-122"/>
                 <a:cs typeface="Calibri" pitchFamily="34" charset="-120"/>
               </a:rPr>
-              <a:t>React artifacts</a:t>
+              <a:t>AI-powered tools</a:t>
             </a:r>
             <a:endParaRPr lang="en-US" sz="1100" dirty="0"/>
           </a:p>
@@ -17396,7 +17376,9 @@
             <a:r>
               <a:rPr lang="en-US" sz="700" b="1" kern="0" spc="200" dirty="0">
                 <a:solidFill>
-                  <a:srgbClr val="8B5CF6"/>
+                  <a:schemeClr val="bg1">
+                    <a:lumMod val="50000"/>
+                  </a:schemeClr>
                 </a:solidFill>
                 <a:latin typeface="Calibri" pitchFamily="34" charset="0"/>
                 <a:ea typeface="Calibri" pitchFamily="34" charset="-122"/>
@@ -17404,7 +17386,13 @@
               </a:rPr>
               <a:t>Figma File</a:t>
             </a:r>
-            <a:endParaRPr lang="en-US" sz="700" dirty="0"/>
+            <a:endParaRPr lang="en-US" sz="700" dirty="0">
+              <a:solidFill>
+                <a:schemeClr val="bg1">
+                  <a:lumMod val="50000"/>
+                </a:schemeClr>
+              </a:solidFill>
+            </a:endParaRPr>
           </a:p>
         </p:txBody>
       </p:sp>
@@ -17667,13 +17655,13 @@
       </p:sp>
       <p:sp>
         <p:nvSpPr>
-          <p:cNvPr id="15" name="Shape 13"/>
-          <p:cNvSpPr/>
-          <p:nvPr/>
-        </p:nvSpPr>
-        <p:spPr>
-          <a:xfrm>
-            <a:off x="454880" y="2029968"/>
+          <p:cNvPr id="15" name="Shape 3"/>
+          <p:cNvSpPr/>
+          <p:nvPr/>
+        </p:nvSpPr>
+        <p:spPr>
+          <a:xfrm>
+            <a:off x="454880" y="1920240"/>
             <a:ext cx="5532120" cy="548640"/>
           </a:xfrm>
           <a:prstGeom prst="rect">
@@ -17699,13 +17687,13 @@
       </p:sp>
       <p:sp>
         <p:nvSpPr>
-          <p:cNvPr id="16" name="Shape 14"/>
-          <p:cNvSpPr/>
-          <p:nvPr/>
-        </p:nvSpPr>
-        <p:spPr>
-          <a:xfrm>
-            <a:off x="454880" y="2029968"/>
+          <p:cNvPr id="16" name="Shape 4"/>
+          <p:cNvSpPr/>
+          <p:nvPr/>
+        </p:nvSpPr>
+        <p:spPr>
+          <a:xfrm>
+            <a:off x="454880" y="1920240"/>
             <a:ext cx="45720" cy="548640"/>
           </a:xfrm>
           <a:prstGeom prst="rect">
@@ -17729,13 +17717,13 @@
       </p:sp>
       <p:sp>
         <p:nvSpPr>
-          <p:cNvPr id="17" name="Text 15"/>
-          <p:cNvSpPr/>
-          <p:nvPr/>
-        </p:nvSpPr>
-        <p:spPr>
-          <a:xfrm>
-            <a:off x="592040" y="2084832"/>
+          <p:cNvPr id="17" name="Text 5"/>
+          <p:cNvSpPr/>
+          <p:nvPr/>
+        </p:nvSpPr>
+        <p:spPr>
+          <a:xfrm>
+            <a:off x="592040" y="1975104"/>
             <a:ext cx="1828800" cy="182880"/>
           </a:xfrm>
           <a:prstGeom prst="rect">
@@ -17754,7 +17742,7 @@
             <a:r>
               <a:rPr lang="en-US" sz="700" b="1" kern="0" spc="200" dirty="0">
                 <a:solidFill>
-                  <a:srgbClr val="22C55E"/>
+                  <a:srgbClr val="21C55D"/>
                 </a:solidFill>
                 <a:latin typeface="Calibri" pitchFamily="34" charset="0"/>
                 <a:ea typeface="Calibri" pitchFamily="34" charset="-122"/>
@@ -17762,19 +17750,23 @@
               </a:rPr>
               <a:t>Skill — 01</a:t>
             </a:r>
-            <a:endParaRPr lang="en-US" sz="700" dirty="0"/>
-          </a:p>
-        </p:txBody>
-      </p:sp>
-      <p:sp>
-        <p:nvSpPr>
-          <p:cNvPr id="18" name="Text 16"/>
-          <p:cNvSpPr/>
-          <p:nvPr/>
-        </p:nvSpPr>
-        <p:spPr>
-          <a:xfrm>
-            <a:off x="592040" y="2295144"/>
+            <a:endParaRPr lang="en-US" sz="700" dirty="0">
+              <a:solidFill>
+                <a:srgbClr val="21C55D"/>
+              </a:solidFill>
+            </a:endParaRPr>
+          </a:p>
+        </p:txBody>
+      </p:sp>
+      <p:sp>
+        <p:nvSpPr>
+          <p:cNvPr id="18" name="Text 6"/>
+          <p:cNvSpPr/>
+          <p:nvPr/>
+        </p:nvSpPr>
+        <p:spPr>
+          <a:xfrm>
+            <a:off x="592040" y="2185416"/>
             <a:ext cx="4114800" cy="219456"/>
           </a:xfrm>
           <a:prstGeom prst="rect">
@@ -17807,14 +17799,14 @@
       </p:sp>
       <p:sp>
         <p:nvSpPr>
-          <p:cNvPr id="19" name="Text 17"/>
-          <p:cNvSpPr/>
-          <p:nvPr/>
-        </p:nvSpPr>
-        <p:spPr>
-          <a:xfrm>
-            <a:off x="4798280" y="2295144"/>
-            <a:ext cx="1051560" cy="219456"/>
+          <p:cNvPr id="19" name="Text 7"/>
+          <p:cNvSpPr/>
+          <p:nvPr/>
+        </p:nvSpPr>
+        <p:spPr>
+          <a:xfrm>
+            <a:off x="4336000" y="2185416"/>
+            <a:ext cx="1513840" cy="73152"/>
           </a:xfrm>
           <a:prstGeom prst="rect">
             <a:avLst/>
@@ -17846,13 +17838,13 @@
       </p:sp>
       <p:sp>
         <p:nvSpPr>
-          <p:cNvPr id="20" name="Shape 18"/>
-          <p:cNvSpPr/>
-          <p:nvPr/>
-        </p:nvSpPr>
-        <p:spPr>
-          <a:xfrm>
-            <a:off x="6215600" y="2029968"/>
+          <p:cNvPr id="20" name="Shape 8"/>
+          <p:cNvSpPr/>
+          <p:nvPr/>
+        </p:nvSpPr>
+        <p:spPr>
+          <a:xfrm>
+            <a:off x="6215600" y="1920240"/>
             <a:ext cx="5532120" cy="548640"/>
           </a:xfrm>
           <a:prstGeom prst="rect">
@@ -17878,13 +17870,13 @@
       </p:sp>
       <p:sp>
         <p:nvSpPr>
-          <p:cNvPr id="21" name="Shape 19"/>
-          <p:cNvSpPr/>
-          <p:nvPr/>
-        </p:nvSpPr>
-        <p:spPr>
-          <a:xfrm>
-            <a:off x="6215600" y="2029968"/>
+          <p:cNvPr id="21" name="Shape 9"/>
+          <p:cNvSpPr/>
+          <p:nvPr/>
+        </p:nvSpPr>
+        <p:spPr>
+          <a:xfrm>
+            <a:off x="6215600" y="1920240"/>
             <a:ext cx="45720" cy="548640"/>
           </a:xfrm>
           <a:prstGeom prst="rect">
@@ -17908,13 +17900,13 @@
       </p:sp>
       <p:sp>
         <p:nvSpPr>
-          <p:cNvPr id="22" name="Text 20"/>
-          <p:cNvSpPr/>
-          <p:nvPr/>
-        </p:nvSpPr>
-        <p:spPr>
-          <a:xfrm>
-            <a:off x="6352760" y="2084832"/>
+          <p:cNvPr id="22" name="Text 10"/>
+          <p:cNvSpPr/>
+          <p:nvPr/>
+        </p:nvSpPr>
+        <p:spPr>
+          <a:xfrm>
+            <a:off x="6352760" y="1975104"/>
             <a:ext cx="1828800" cy="182880"/>
           </a:xfrm>
           <a:prstGeom prst="rect">
@@ -17941,19 +17933,23 @@
               </a:rPr>
               <a:t>Skill — 02</a:t>
             </a:r>
-            <a:endParaRPr lang="en-US" sz="700" dirty="0"/>
-          </a:p>
-        </p:txBody>
-      </p:sp>
-      <p:sp>
-        <p:nvSpPr>
-          <p:cNvPr id="23" name="Text 21"/>
-          <p:cNvSpPr/>
-          <p:nvPr/>
-        </p:nvSpPr>
-        <p:spPr>
-          <a:xfrm>
-            <a:off x="6352760" y="2295144"/>
+            <a:endParaRPr lang="en-US" sz="700" dirty="0">
+              <a:solidFill>
+                <a:srgbClr val="8B5CF6"/>
+              </a:solidFill>
+            </a:endParaRPr>
+          </a:p>
+        </p:txBody>
+      </p:sp>
+      <p:sp>
+        <p:nvSpPr>
+          <p:cNvPr id="23" name="Text 11"/>
+          <p:cNvSpPr/>
+          <p:nvPr/>
+        </p:nvSpPr>
+        <p:spPr>
+          <a:xfrm>
+            <a:off x="6352760" y="2185416"/>
             <a:ext cx="4114800" cy="219456"/>
           </a:xfrm>
           <a:prstGeom prst="rect">
@@ -17986,13 +17982,13 @@
       </p:sp>
       <p:sp>
         <p:nvSpPr>
-          <p:cNvPr id="24" name="Text 22"/>
-          <p:cNvSpPr/>
-          <p:nvPr/>
-        </p:nvSpPr>
-        <p:spPr>
-          <a:xfrm>
-            <a:off x="10559000" y="2295144"/>
+          <p:cNvPr id="24" name="Text 12"/>
+          <p:cNvSpPr/>
+          <p:nvPr/>
+        </p:nvSpPr>
+        <p:spPr>
+          <a:xfrm>
+            <a:off x="10559000" y="2185416"/>
             <a:ext cx="1051560" cy="219456"/>
           </a:xfrm>
           <a:prstGeom prst="rect">
@@ -18025,13 +18021,13 @@
       </p:sp>
       <p:sp>
         <p:nvSpPr>
-          <p:cNvPr id="25" name="Shape 23"/>
-          <p:cNvSpPr/>
-          <p:nvPr/>
-        </p:nvSpPr>
-        <p:spPr>
-          <a:xfrm>
-            <a:off x="454880" y="2688336"/>
+          <p:cNvPr id="25" name="Shape 3"/>
+          <p:cNvSpPr/>
+          <p:nvPr/>
+        </p:nvSpPr>
+        <p:spPr>
+          <a:xfrm>
+            <a:off x="454880" y="2468880"/>
             <a:ext cx="5532120" cy="548640"/>
           </a:xfrm>
           <a:prstGeom prst="rect">
@@ -18057,13 +18053,13 @@
       </p:sp>
       <p:sp>
         <p:nvSpPr>
-          <p:cNvPr id="26" name="Shape 24"/>
-          <p:cNvSpPr/>
-          <p:nvPr/>
-        </p:nvSpPr>
-        <p:spPr>
-          <a:xfrm>
-            <a:off x="454880" y="2688336"/>
+          <p:cNvPr id="26" name="Shape 4"/>
+          <p:cNvSpPr/>
+          <p:nvPr/>
+        </p:nvSpPr>
+        <p:spPr>
+          <a:xfrm>
+            <a:off x="454880" y="2468880"/>
             <a:ext cx="45720" cy="548640"/>
           </a:xfrm>
           <a:prstGeom prst="rect">
@@ -18087,13 +18083,13 @@
       </p:sp>
       <p:sp>
         <p:nvSpPr>
-          <p:cNvPr id="27" name="Text 25"/>
-          <p:cNvSpPr/>
-          <p:nvPr/>
-        </p:nvSpPr>
-        <p:spPr>
-          <a:xfrm>
-            <a:off x="592040" y="2743200"/>
+          <p:cNvPr id="27" name="Text 5"/>
+          <p:cNvSpPr/>
+          <p:nvPr/>
+        </p:nvSpPr>
+        <p:spPr>
+          <a:xfrm>
+            <a:off x="592040" y="2523744"/>
             <a:ext cx="1828800" cy="182880"/>
           </a:xfrm>
           <a:prstGeom prst="rect">
@@ -18112,7 +18108,7 @@
             <a:r>
               <a:rPr lang="en-US" sz="700" b="1" kern="0" spc="200" dirty="0">
                 <a:solidFill>
-                  <a:srgbClr val="F59E0B"/>
+                  <a:srgbClr val="F69E0B"/>
                 </a:solidFill>
                 <a:latin typeface="Calibri" pitchFamily="34" charset="0"/>
                 <a:ea typeface="Calibri" pitchFamily="34" charset="-122"/>
@@ -18120,19 +18116,23 @@
               </a:rPr>
               <a:t>Skill — 03</a:t>
             </a:r>
-            <a:endParaRPr lang="en-US" sz="700" dirty="0"/>
-          </a:p>
-        </p:txBody>
-      </p:sp>
-      <p:sp>
-        <p:nvSpPr>
-          <p:cNvPr id="28" name="Text 26"/>
-          <p:cNvSpPr/>
-          <p:nvPr/>
-        </p:nvSpPr>
-        <p:spPr>
-          <a:xfrm>
-            <a:off x="592040" y="2953512"/>
+            <a:endParaRPr lang="en-US" sz="700" dirty="0">
+              <a:solidFill>
+                <a:srgbClr val="F69E0B"/>
+              </a:solidFill>
+            </a:endParaRPr>
+          </a:p>
+        </p:txBody>
+      </p:sp>
+      <p:sp>
+        <p:nvSpPr>
+          <p:cNvPr id="28" name="Text 6"/>
+          <p:cNvSpPr/>
+          <p:nvPr/>
+        </p:nvSpPr>
+        <p:spPr>
+          <a:xfrm>
+            <a:off x="592040" y="2734056"/>
             <a:ext cx="4114800" cy="219456"/>
           </a:xfrm>
           <a:prstGeom prst="rect">
@@ -18165,14 +18165,14 @@
       </p:sp>
       <p:sp>
         <p:nvSpPr>
-          <p:cNvPr id="29" name="Text 27"/>
-          <p:cNvSpPr/>
-          <p:nvPr/>
-        </p:nvSpPr>
-        <p:spPr>
-          <a:xfrm>
-            <a:off x="4798280" y="2953512"/>
-            <a:ext cx="1051560" cy="219456"/>
+          <p:cNvPr id="29" name="Text 7"/>
+          <p:cNvSpPr/>
+          <p:nvPr/>
+        </p:nvSpPr>
+        <p:spPr>
+          <a:xfrm>
+            <a:off x="4336000" y="2734056"/>
+            <a:ext cx="1513840" cy="73152"/>
           </a:xfrm>
           <a:prstGeom prst="rect">
             <a:avLst/>
@@ -18204,13 +18204,13 @@
       </p:sp>
       <p:sp>
         <p:nvSpPr>
-          <p:cNvPr id="30" name="Shape 28"/>
-          <p:cNvSpPr/>
-          <p:nvPr/>
-        </p:nvSpPr>
-        <p:spPr>
-          <a:xfrm>
-            <a:off x="6215600" y="2688336"/>
+          <p:cNvPr id="30" name="Shape 8"/>
+          <p:cNvSpPr/>
+          <p:nvPr/>
+        </p:nvSpPr>
+        <p:spPr>
+          <a:xfrm>
+            <a:off x="6215600" y="2468880"/>
             <a:ext cx="5532120" cy="548640"/>
           </a:xfrm>
           <a:prstGeom prst="rect">
@@ -18236,20 +18236,20 @@
       </p:sp>
       <p:sp>
         <p:nvSpPr>
-          <p:cNvPr id="31" name="Shape 29"/>
-          <p:cNvSpPr/>
-          <p:nvPr/>
-        </p:nvSpPr>
-        <p:spPr>
-          <a:xfrm>
-            <a:off x="6215600" y="2688336"/>
+          <p:cNvPr id="31" name="Shape 9"/>
+          <p:cNvSpPr/>
+          <p:nvPr/>
+        </p:nvSpPr>
+        <p:spPr>
+          <a:xfrm>
+            <a:off x="6215600" y="2468880"/>
             <a:ext cx="45720" cy="548640"/>
           </a:xfrm>
           <a:prstGeom prst="rect">
             <a:avLst/>
           </a:prstGeom>
           <a:solidFill>
-            <a:srgbClr val="3B82F6"/>
+            <a:srgbClr val="F59E0B"/>
           </a:solidFill>
           <a:ln w="12700">
             <a:noFill/>
@@ -18266,13 +18266,13 @@
       </p:sp>
       <p:sp>
         <p:nvSpPr>
-          <p:cNvPr id="32" name="Text 30"/>
-          <p:cNvSpPr/>
-          <p:nvPr/>
-        </p:nvSpPr>
-        <p:spPr>
-          <a:xfrm>
-            <a:off x="6352760" y="2743200"/>
+          <p:cNvPr id="32" name="Text 10"/>
+          <p:cNvSpPr/>
+          <p:nvPr/>
+        </p:nvSpPr>
+        <p:spPr>
+          <a:xfrm>
+            <a:off x="6352760" y="2523744"/>
             <a:ext cx="1828800" cy="182880"/>
           </a:xfrm>
           <a:prstGeom prst="rect">
@@ -18291,27 +18291,31 @@
             <a:r>
               <a:rPr lang="en-US" sz="700" b="1" kern="0" spc="200" dirty="0">
                 <a:solidFill>
-                  <a:srgbClr val="3B82F6"/>
-                </a:solidFill>
-                <a:latin typeface="Calibri" pitchFamily="34" charset="0"/>
-                <a:ea typeface="Calibri" pitchFamily="34" charset="-122"/>
-                <a:cs typeface="Calibri" pitchFamily="34" charset="-120"/>
-              </a:rPr>
-              <a:t>Skill — 04</a:t>
-            </a:r>
-            <a:endParaRPr lang="en-US" sz="700" dirty="0"/>
-          </a:p>
-        </p:txBody>
-      </p:sp>
-      <p:sp>
-        <p:nvSpPr>
-          <p:cNvPr id="33" name="Text 31"/>
-          <p:cNvSpPr/>
-          <p:nvPr/>
-        </p:nvSpPr>
-        <p:spPr>
-          <a:xfrm>
-            <a:off x="6352760" y="2953512"/>
+                  <a:srgbClr val="F69E0B"/>
+                </a:solidFill>
+                <a:latin typeface="Calibri" pitchFamily="34" charset="0"/>
+                <a:ea typeface="Calibri" pitchFamily="34" charset="-122"/>
+                <a:cs typeface="Calibri" pitchFamily="34" charset="-120"/>
+              </a:rPr>
+              <a:t>Skill — 03</a:t>
+            </a:r>
+            <a:endParaRPr lang="en-US" sz="700" dirty="0">
+              <a:solidFill>
+                <a:srgbClr val="F69E0B"/>
+              </a:solidFill>
+            </a:endParaRPr>
+          </a:p>
+        </p:txBody>
+      </p:sp>
+      <p:sp>
+        <p:nvSpPr>
+          <p:cNvPr id="33" name="Text 11"/>
+          <p:cNvSpPr/>
+          <p:nvPr/>
+        </p:nvSpPr>
+        <p:spPr>
+          <a:xfrm>
+            <a:off x="6352760" y="2734056"/>
             <a:ext cx="4114800" cy="219456"/>
           </a:xfrm>
           <a:prstGeom prst="rect">
@@ -18336,7 +18340,7 @@
                 <a:ea typeface="Calibri" pitchFamily="34" charset="-122"/>
                 <a:cs typeface="Calibri" pitchFamily="34" charset="-120"/>
               </a:rPr>
-              <a:t>prototyping.md</a:t>
+              <a:t>visual-design-execution.md</a:t>
             </a:r>
             <a:endParaRPr lang="en-US" sz="1200" dirty="0"/>
           </a:p>
@@ -18344,13 +18348,13 @@
       </p:sp>
       <p:sp>
         <p:nvSpPr>
-          <p:cNvPr id="34" name="Text 32"/>
-          <p:cNvSpPr/>
-          <p:nvPr/>
-        </p:nvSpPr>
-        <p:spPr>
-          <a:xfrm>
-            <a:off x="10559000" y="2953512"/>
+          <p:cNvPr id="34" name="Text 12"/>
+          <p:cNvSpPr/>
+          <p:nvPr/>
+        </p:nvSpPr>
+        <p:spPr>
+          <a:xfrm>
+            <a:off x="10559000" y="2734056"/>
             <a:ext cx="1051560" cy="219456"/>
           </a:xfrm>
           <a:prstGeom prst="rect">
@@ -18375,7 +18379,7 @@
                 <a:ea typeface="Calibri" pitchFamily="34" charset="-122"/>
                 <a:cs typeface="Calibri" pitchFamily="34" charset="-120"/>
               </a:rPr>
-              <a:t>Prototype</a:t>
+              <a:t>Ideate</a:t>
             </a:r>
             <a:endParaRPr lang="en-US" sz="1000" dirty="0"/>
           </a:p>
@@ -18383,13 +18387,13 @@
       </p:sp>
       <p:sp>
         <p:nvSpPr>
-          <p:cNvPr id="35" name="Shape 33"/>
-          <p:cNvSpPr/>
-          <p:nvPr/>
-        </p:nvSpPr>
-        <p:spPr>
-          <a:xfrm>
-            <a:off x="454880" y="3346704"/>
+          <p:cNvPr id="35" name="Shape 3"/>
+          <p:cNvSpPr/>
+          <p:nvPr/>
+        </p:nvSpPr>
+        <p:spPr>
+          <a:xfrm>
+            <a:off x="454880" y="3017520"/>
             <a:ext cx="5532120" cy="548640"/>
           </a:xfrm>
           <a:prstGeom prst="rect">
@@ -18415,20 +18419,20 @@
       </p:sp>
       <p:sp>
         <p:nvSpPr>
-          <p:cNvPr id="36" name="Shape 34"/>
-          <p:cNvSpPr/>
-          <p:nvPr/>
-        </p:nvSpPr>
-        <p:spPr>
-          <a:xfrm>
-            <a:off x="454880" y="3346704"/>
+          <p:cNvPr id="36" name="Shape 4"/>
+          <p:cNvSpPr/>
+          <p:nvPr/>
+        </p:nvSpPr>
+        <p:spPr>
+          <a:xfrm>
+            <a:off x="454880" y="3017520"/>
             <a:ext cx="45720" cy="548640"/>
           </a:xfrm>
           <a:prstGeom prst="rect">
             <a:avLst/>
           </a:prstGeom>
           <a:solidFill>
-            <a:srgbClr val="EF4444"/>
+            <a:srgbClr val="3B82F6"/>
           </a:solidFill>
           <a:ln w="12700">
             <a:noFill/>
@@ -18445,13 +18449,13 @@
       </p:sp>
       <p:sp>
         <p:nvSpPr>
-          <p:cNvPr id="37" name="Text 35"/>
-          <p:cNvSpPr/>
-          <p:nvPr/>
-        </p:nvSpPr>
-        <p:spPr>
-          <a:xfrm>
-            <a:off x="592040" y="3401568"/>
+          <p:cNvPr id="37" name="Text 5"/>
+          <p:cNvSpPr/>
+          <p:nvPr/>
+        </p:nvSpPr>
+        <p:spPr>
+          <a:xfrm>
+            <a:off x="592040" y="3072384"/>
             <a:ext cx="1828800" cy="182880"/>
           </a:xfrm>
           <a:prstGeom prst="rect">
@@ -18470,27 +18474,31 @@
             <a:r>
               <a:rPr lang="en-US" sz="700" b="1" kern="0" spc="200" dirty="0">
                 <a:solidFill>
-                  <a:srgbClr val="EF4444"/>
-                </a:solidFill>
-                <a:latin typeface="Calibri" pitchFamily="34" charset="0"/>
-                <a:ea typeface="Calibri" pitchFamily="34" charset="-122"/>
-                <a:cs typeface="Calibri" pitchFamily="34" charset="-120"/>
-              </a:rPr>
-              <a:t>Skill — 05</a:t>
-            </a:r>
-            <a:endParaRPr lang="en-US" sz="700" dirty="0"/>
-          </a:p>
-        </p:txBody>
-      </p:sp>
-      <p:sp>
-        <p:nvSpPr>
-          <p:cNvPr id="38" name="Text 36"/>
-          <p:cNvSpPr/>
-          <p:nvPr/>
-        </p:nvSpPr>
-        <p:spPr>
-          <a:xfrm>
-            <a:off x="592040" y="3611880"/>
+                  <a:srgbClr val="3B82F6"/>
+                </a:solidFill>
+                <a:latin typeface="Calibri" pitchFamily="34" charset="0"/>
+                <a:ea typeface="Calibri" pitchFamily="34" charset="-122"/>
+                <a:cs typeface="Calibri" pitchFamily="34" charset="-120"/>
+              </a:rPr>
+              <a:t>Skill — 04</a:t>
+            </a:r>
+            <a:endParaRPr lang="en-US" sz="700" dirty="0">
+              <a:solidFill>
+                <a:srgbClr val="3B82F6"/>
+              </a:solidFill>
+            </a:endParaRPr>
+          </a:p>
+        </p:txBody>
+      </p:sp>
+      <p:sp>
+        <p:nvSpPr>
+          <p:cNvPr id="38" name="Text 6"/>
+          <p:cNvSpPr/>
+          <p:nvPr/>
+        </p:nvSpPr>
+        <p:spPr>
+          <a:xfrm>
+            <a:off x="592040" y="3282696"/>
             <a:ext cx="4114800" cy="219456"/>
           </a:xfrm>
           <a:prstGeom prst="rect">
@@ -18515,7 +18523,7 @@
                 <a:ea typeface="Calibri" pitchFamily="34" charset="-122"/>
                 <a:cs typeface="Calibri" pitchFamily="34" charset="-120"/>
               </a:rPr>
-              <a:t>usability-testing.md</a:t>
+              <a:t>prototyping.md</a:t>
             </a:r>
             <a:endParaRPr lang="en-US" sz="1200" dirty="0"/>
           </a:p>
@@ -18523,14 +18531,14 @@
       </p:sp>
       <p:sp>
         <p:nvSpPr>
-          <p:cNvPr id="39" name="Text 37"/>
-          <p:cNvSpPr/>
-          <p:nvPr/>
-        </p:nvSpPr>
-        <p:spPr>
-          <a:xfrm>
-            <a:off x="4798280" y="3611880"/>
-            <a:ext cx="1051560" cy="219456"/>
+          <p:cNvPr id="39" name="Text 7"/>
+          <p:cNvSpPr/>
+          <p:nvPr/>
+        </p:nvSpPr>
+        <p:spPr>
+          <a:xfrm>
+            <a:off x="4336000" y="3282696"/>
+            <a:ext cx="1513840" cy="73152"/>
           </a:xfrm>
           <a:prstGeom prst="rect">
             <a:avLst/>
@@ -18554,7 +18562,7 @@
                 <a:ea typeface="Calibri" pitchFamily="34" charset="-122"/>
                 <a:cs typeface="Calibri" pitchFamily="34" charset="-120"/>
               </a:rPr>
-              <a:t>Validate</a:t>
+              <a:t>Prototype</a:t>
             </a:r>
             <a:endParaRPr lang="en-US" sz="1000" dirty="0"/>
           </a:p>
@@ -18562,13 +18570,13 @@
       </p:sp>
       <p:sp>
         <p:nvSpPr>
-          <p:cNvPr id="40" name="Shape 38"/>
-          <p:cNvSpPr/>
-          <p:nvPr/>
-        </p:nvSpPr>
-        <p:spPr>
-          <a:xfrm>
-            <a:off x="6215600" y="3346704"/>
+          <p:cNvPr id="40" name="Shape 8"/>
+          <p:cNvSpPr/>
+          <p:nvPr/>
+        </p:nvSpPr>
+        <p:spPr>
+          <a:xfrm>
+            <a:off x="6215600" y="3017520"/>
             <a:ext cx="5532120" cy="548640"/>
           </a:xfrm>
           <a:prstGeom prst="rect">
@@ -18594,20 +18602,20 @@
       </p:sp>
       <p:sp>
         <p:nvSpPr>
-          <p:cNvPr id="41" name="Shape 39"/>
-          <p:cNvSpPr/>
-          <p:nvPr/>
-        </p:nvSpPr>
-        <p:spPr>
-          <a:xfrm>
-            <a:off x="6215600" y="3346704"/>
+          <p:cNvPr id="41" name="Shape 9"/>
+          <p:cNvSpPr/>
+          <p:nvPr/>
+        </p:nvSpPr>
+        <p:spPr>
+          <a:xfrm>
+            <a:off x="6215600" y="3017520"/>
             <a:ext cx="45720" cy="548640"/>
           </a:xfrm>
           <a:prstGeom prst="rect">
             <a:avLst/>
           </a:prstGeom>
           <a:solidFill>
-            <a:srgbClr val="14B8A6"/>
+            <a:srgbClr val="3B82F6"/>
           </a:solidFill>
           <a:ln w="12700">
             <a:noFill/>
@@ -18624,13 +18632,13 @@
       </p:sp>
       <p:sp>
         <p:nvSpPr>
-          <p:cNvPr id="42" name="Text 40"/>
-          <p:cNvSpPr/>
-          <p:nvPr/>
-        </p:nvSpPr>
-        <p:spPr>
-          <a:xfrm>
-            <a:off x="6352760" y="3401568"/>
+          <p:cNvPr id="42" name="Text 10"/>
+          <p:cNvSpPr/>
+          <p:nvPr/>
+        </p:nvSpPr>
+        <p:spPr>
+          <a:xfrm>
+            <a:off x="6352760" y="3072384"/>
             <a:ext cx="1828800" cy="182880"/>
           </a:xfrm>
           <a:prstGeom prst="rect">
@@ -18649,27 +18657,31 @@
             <a:r>
               <a:rPr lang="en-US" sz="700" b="1" kern="0" spc="200" dirty="0">
                 <a:solidFill>
-                  <a:srgbClr val="14B8A6"/>
-                </a:solidFill>
-                <a:latin typeface="Calibri" pitchFamily="34" charset="0"/>
-                <a:ea typeface="Calibri" pitchFamily="34" charset="-122"/>
-                <a:cs typeface="Calibri" pitchFamily="34" charset="-120"/>
-              </a:rPr>
-              <a:t>Skill — 06</a:t>
-            </a:r>
-            <a:endParaRPr lang="en-US" sz="700" dirty="0"/>
-          </a:p>
-        </p:txBody>
-      </p:sp>
-      <p:sp>
-        <p:nvSpPr>
-          <p:cNvPr id="43" name="Text 41"/>
-          <p:cNvSpPr/>
-          <p:nvPr/>
-        </p:nvSpPr>
-        <p:spPr>
-          <a:xfrm>
-            <a:off x="6352760" y="3611880"/>
+                  <a:srgbClr val="3B82F6"/>
+                </a:solidFill>
+                <a:latin typeface="Calibri" pitchFamily="34" charset="0"/>
+                <a:ea typeface="Calibri" pitchFamily="34" charset="-122"/>
+                <a:cs typeface="Calibri" pitchFamily="34" charset="-120"/>
+              </a:rPr>
+              <a:t>Skill — 04</a:t>
+            </a:r>
+            <a:endParaRPr lang="en-US" sz="700" dirty="0">
+              <a:solidFill>
+                <a:srgbClr val="3B82F6"/>
+              </a:solidFill>
+            </a:endParaRPr>
+          </a:p>
+        </p:txBody>
+      </p:sp>
+      <p:sp>
+        <p:nvSpPr>
+          <p:cNvPr id="43" name="Text 11"/>
+          <p:cNvSpPr/>
+          <p:nvPr/>
+        </p:nvSpPr>
+        <p:spPr>
+          <a:xfrm>
+            <a:off x="6352760" y="3282696"/>
             <a:ext cx="4114800" cy="219456"/>
           </a:xfrm>
           <a:prstGeom prst="rect">
@@ -18694,7 +18706,7 @@
                 <a:ea typeface="Calibri" pitchFamily="34" charset="-122"/>
                 <a:cs typeface="Calibri" pitchFamily="34" charset="-120"/>
               </a:rPr>
-              <a:t>design-delivery.md</a:t>
+              <a:t>accessibility-audit.md</a:t>
             </a:r>
             <a:endParaRPr lang="en-US" sz="1200" dirty="0"/>
           </a:p>
@@ -18702,13 +18714,13 @@
       </p:sp>
       <p:sp>
         <p:nvSpPr>
-          <p:cNvPr id="44" name="Text 42"/>
-          <p:cNvSpPr/>
-          <p:nvPr/>
-        </p:nvSpPr>
-        <p:spPr>
-          <a:xfrm>
-            <a:off x="10559000" y="3611880"/>
+          <p:cNvPr id="44" name="Text 12"/>
+          <p:cNvSpPr/>
+          <p:nvPr/>
+        </p:nvSpPr>
+        <p:spPr>
+          <a:xfrm>
+            <a:off x="10559000" y="3282696"/>
             <a:ext cx="1051560" cy="219456"/>
           </a:xfrm>
           <a:prstGeom prst="rect">
@@ -18733,7 +18745,7 @@
                 <a:ea typeface="Calibri" pitchFamily="34" charset="-122"/>
                 <a:cs typeface="Calibri" pitchFamily="34" charset="-120"/>
               </a:rPr>
-              <a:t>Deliver</a:t>
+              <a:t>Prototype</a:t>
             </a:r>
             <a:endParaRPr lang="en-US" sz="1000" dirty="0"/>
           </a:p>
@@ -18741,13 +18753,13 @@
       </p:sp>
       <p:sp>
         <p:nvSpPr>
-          <p:cNvPr id="45" name="Shape 43"/>
-          <p:cNvSpPr/>
-          <p:nvPr/>
-        </p:nvSpPr>
-        <p:spPr>
-          <a:xfrm>
-            <a:off x="454880" y="4005072"/>
+          <p:cNvPr id="45" name="Shape 3"/>
+          <p:cNvSpPr/>
+          <p:nvPr/>
+        </p:nvSpPr>
+        <p:spPr>
+          <a:xfrm>
+            <a:off x="454880" y="3566160"/>
             <a:ext cx="5532120" cy="548640"/>
           </a:xfrm>
           <a:prstGeom prst="rect">
@@ -18773,20 +18785,20 @@
       </p:sp>
       <p:sp>
         <p:nvSpPr>
-          <p:cNvPr id="46" name="Shape 44"/>
-          <p:cNvSpPr/>
-          <p:nvPr/>
-        </p:nvSpPr>
-        <p:spPr>
-          <a:xfrm>
-            <a:off x="454880" y="4005072"/>
+          <p:cNvPr id="46" name="Shape 4"/>
+          <p:cNvSpPr/>
+          <p:nvPr/>
+        </p:nvSpPr>
+        <p:spPr>
+          <a:xfrm>
+            <a:off x="454880" y="3566160"/>
             <a:ext cx="45720" cy="548640"/>
           </a:xfrm>
           <a:prstGeom prst="rect">
             <a:avLst/>
           </a:prstGeom>
           <a:solidFill>
-            <a:srgbClr val="F69E0B"/>
+            <a:srgbClr val="EF4444"/>
           </a:solidFill>
           <a:ln w="12700">
             <a:noFill/>
@@ -18803,13 +18815,13 @@
       </p:sp>
       <p:sp>
         <p:nvSpPr>
-          <p:cNvPr id="47" name="Text 45"/>
-          <p:cNvSpPr/>
-          <p:nvPr/>
-        </p:nvSpPr>
-        <p:spPr>
-          <a:xfrm>
-            <a:off x="592040" y="4059936"/>
+          <p:cNvPr id="47" name="Text 5"/>
+          <p:cNvSpPr/>
+          <p:nvPr/>
+        </p:nvSpPr>
+        <p:spPr>
+          <a:xfrm>
+            <a:off x="592040" y="3621024"/>
             <a:ext cx="1828800" cy="182880"/>
           </a:xfrm>
           <a:prstGeom prst="rect">
@@ -18828,27 +18840,31 @@
             <a:r>
               <a:rPr lang="en-US" sz="700" b="1" kern="0" spc="200" dirty="0">
                 <a:solidFill>
-                  <a:srgbClr val="F59E0B"/>
-                </a:solidFill>
-                <a:latin typeface="Calibri" pitchFamily="34" charset="0"/>
-                <a:ea typeface="Calibri" pitchFamily="34" charset="-122"/>
-                <a:cs typeface="Calibri" pitchFamily="34" charset="-120"/>
-              </a:rPr>
-              <a:t>Skill — 03/06</a:t>
-            </a:r>
-            <a:endParaRPr lang="en-US" sz="700" dirty="0"/>
-          </a:p>
-        </p:txBody>
-      </p:sp>
-      <p:sp>
-        <p:nvSpPr>
-          <p:cNvPr id="48" name="Text 46"/>
-          <p:cNvSpPr/>
-          <p:nvPr/>
-        </p:nvSpPr>
-        <p:spPr>
-          <a:xfrm>
-            <a:off x="592040" y="4270248"/>
+                  <a:srgbClr val="EF4444"/>
+                </a:solidFill>
+                <a:latin typeface="Calibri" pitchFamily="34" charset="0"/>
+                <a:ea typeface="Calibri" pitchFamily="34" charset="-122"/>
+                <a:cs typeface="Calibri" pitchFamily="34" charset="-120"/>
+              </a:rPr>
+              <a:t>Skill — 05</a:t>
+            </a:r>
+            <a:endParaRPr lang="en-US" sz="700" dirty="0">
+              <a:solidFill>
+                <a:srgbClr val="EF4444"/>
+              </a:solidFill>
+            </a:endParaRPr>
+          </a:p>
+        </p:txBody>
+      </p:sp>
+      <p:sp>
+        <p:nvSpPr>
+          <p:cNvPr id="48" name="Text 6"/>
+          <p:cNvSpPr/>
+          <p:nvPr/>
+        </p:nvSpPr>
+        <p:spPr>
+          <a:xfrm>
+            <a:off x="592040" y="3831335"/>
             <a:ext cx="4114800" cy="219456"/>
           </a:xfrm>
           <a:prstGeom prst="rect">
@@ -18873,7 +18889,7 @@
                 <a:ea typeface="Calibri" pitchFamily="34" charset="-122"/>
                 <a:cs typeface="Calibri" pitchFamily="34" charset="-120"/>
               </a:rPr>
-              <a:t>design-systems.md</a:t>
+              <a:t>usability-testing.md</a:t>
             </a:r>
             <a:endParaRPr lang="en-US" sz="1200" dirty="0"/>
           </a:p>
@@ -18881,14 +18897,14 @@
       </p:sp>
       <p:sp>
         <p:nvSpPr>
-          <p:cNvPr id="49" name="Text 47"/>
-          <p:cNvSpPr/>
-          <p:nvPr/>
-        </p:nvSpPr>
-        <p:spPr>
-          <a:xfrm>
-            <a:off x="4798280" y="4270248"/>
-            <a:ext cx="1051560" cy="219456"/>
+          <p:cNvPr id="49" name="Text 7"/>
+          <p:cNvSpPr/>
+          <p:nvPr/>
+        </p:nvSpPr>
+        <p:spPr>
+          <a:xfrm>
+            <a:off x="4336000" y="3831335"/>
+            <a:ext cx="1513840" cy="73152"/>
           </a:xfrm>
           <a:prstGeom prst="rect">
             <a:avLst/>
@@ -18912,7 +18928,7 @@
                 <a:ea typeface="Calibri" pitchFamily="34" charset="-122"/>
                 <a:cs typeface="Calibri" pitchFamily="34" charset="-120"/>
               </a:rPr>
-              <a:t>Ideate + Deliver</a:t>
+              <a:t>Validate</a:t>
             </a:r>
             <a:endParaRPr lang="en-US" sz="1000" dirty="0"/>
           </a:p>
@@ -18920,13 +18936,13 @@
       </p:sp>
       <p:sp>
         <p:nvSpPr>
-          <p:cNvPr id="50" name="Shape 48"/>
-          <p:cNvSpPr/>
-          <p:nvPr/>
-        </p:nvSpPr>
-        <p:spPr>
-          <a:xfrm>
-            <a:off x="6215600" y="4005072"/>
+          <p:cNvPr id="50" name="Shape 8"/>
+          <p:cNvSpPr/>
+          <p:nvPr/>
+        </p:nvSpPr>
+        <p:spPr>
+          <a:xfrm>
+            <a:off x="6215600" y="3566160"/>
             <a:ext cx="5532120" cy="548640"/>
           </a:xfrm>
           <a:prstGeom prst="rect">
@@ -18952,20 +18968,20 @@
       </p:sp>
       <p:sp>
         <p:nvSpPr>
-          <p:cNvPr id="51" name="Shape 49"/>
-          <p:cNvSpPr/>
-          <p:nvPr/>
-        </p:nvSpPr>
-        <p:spPr>
-          <a:xfrm>
-            <a:off x="6215600" y="4005072"/>
+          <p:cNvPr id="51" name="Shape 9"/>
+          <p:cNvSpPr/>
+          <p:nvPr/>
+        </p:nvSpPr>
+        <p:spPr>
+          <a:xfrm>
+            <a:off x="6215600" y="3566160"/>
             <a:ext cx="45720" cy="548640"/>
           </a:xfrm>
           <a:prstGeom prst="rect">
             <a:avLst/>
           </a:prstGeom>
           <a:solidFill>
-            <a:schemeClr val="bg2"/>
+            <a:srgbClr val="14B8A6"/>
           </a:solidFill>
           <a:ln w="12700">
             <a:noFill/>
@@ -18982,13 +18998,13 @@
       </p:sp>
       <p:sp>
         <p:nvSpPr>
-          <p:cNvPr id="52" name="Text 50"/>
-          <p:cNvSpPr/>
-          <p:nvPr/>
-        </p:nvSpPr>
-        <p:spPr>
-          <a:xfrm>
-            <a:off x="6352760" y="4059936"/>
+          <p:cNvPr id="52" name="Text 10"/>
+          <p:cNvSpPr/>
+          <p:nvPr/>
+        </p:nvSpPr>
+        <p:spPr>
+          <a:xfrm>
+            <a:off x="6352760" y="3621024"/>
             <a:ext cx="1828800" cy="182880"/>
           </a:xfrm>
           <a:prstGeom prst="rect">
@@ -19007,35 +19023,27 @@
             <a:r>
               <a:rPr lang="en-US" sz="700" b="1" kern="0" spc="200" dirty="0">
                 <a:solidFill>
-                  <a:schemeClr val="bg1">
-                    <a:lumMod val="50000"/>
-                  </a:schemeClr>
-                </a:solidFill>
-                <a:latin typeface="Calibri" pitchFamily="34" charset="0"/>
-                <a:ea typeface="Calibri" pitchFamily="34" charset="-122"/>
-                <a:cs typeface="Calibri" pitchFamily="34" charset="-120"/>
-              </a:rPr>
-              <a:t>Skill — ALL</a:t>
-            </a:r>
-            <a:endParaRPr lang="en-US" sz="700" dirty="0">
-              <a:solidFill>
-                <a:schemeClr val="bg1">
-                  <a:lumMod val="50000"/>
-                </a:schemeClr>
-              </a:solidFill>
-            </a:endParaRPr>
-          </a:p>
-        </p:txBody>
-      </p:sp>
-      <p:sp>
-        <p:nvSpPr>
-          <p:cNvPr id="53" name="Text 51"/>
-          <p:cNvSpPr/>
-          <p:nvPr/>
-        </p:nvSpPr>
-        <p:spPr>
-          <a:xfrm>
-            <a:off x="6352760" y="4270248"/>
+                  <a:srgbClr val="22C55E"/>
+                </a:solidFill>
+                <a:latin typeface="Calibri" pitchFamily="34" charset="0"/>
+                <a:ea typeface="Calibri" pitchFamily="34" charset="-122"/>
+                <a:cs typeface="Calibri" pitchFamily="34" charset="-120"/>
+              </a:rPr>
+              <a:t>Skill — 06</a:t>
+            </a:r>
+            <a:endParaRPr lang="en-US" sz="700" dirty="0"/>
+          </a:p>
+        </p:txBody>
+      </p:sp>
+      <p:sp>
+        <p:nvSpPr>
+          <p:cNvPr id="53" name="Text 11"/>
+          <p:cNvSpPr/>
+          <p:nvPr/>
+        </p:nvSpPr>
+        <p:spPr>
+          <a:xfrm>
+            <a:off x="6352760" y="3831335"/>
             <a:ext cx="4114800" cy="219456"/>
           </a:xfrm>
           <a:prstGeom prst="rect">
@@ -19060,7 +19068,7 @@
                 <a:ea typeface="Calibri" pitchFamily="34" charset="-122"/>
                 <a:cs typeface="Calibri" pitchFamily="34" charset="-120"/>
               </a:rPr>
-              <a:t>figma-playbook.md</a:t>
+              <a:t>design-delivery.md</a:t>
             </a:r>
             <a:endParaRPr lang="en-US" sz="1200" dirty="0"/>
           </a:p>
@@ -19068,13 +19076,13 @@
       </p:sp>
       <p:sp>
         <p:nvSpPr>
-          <p:cNvPr id="54" name="Text 52"/>
-          <p:cNvSpPr/>
-          <p:nvPr/>
-        </p:nvSpPr>
-        <p:spPr>
-          <a:xfrm>
-            <a:off x="10559000" y="4270248"/>
+          <p:cNvPr id="54" name="Text 12"/>
+          <p:cNvSpPr/>
+          <p:nvPr/>
+        </p:nvSpPr>
+        <p:spPr>
+          <a:xfrm>
+            <a:off x="10559000" y="3831335"/>
             <a:ext cx="1051560" cy="219456"/>
           </a:xfrm>
           <a:prstGeom prst="rect">
@@ -19099,7 +19107,7 @@
                 <a:ea typeface="Calibri" pitchFamily="34" charset="-122"/>
                 <a:cs typeface="Calibri" pitchFamily="34" charset="-120"/>
               </a:rPr>
-              <a:t>All phases</a:t>
+              <a:t>Deliver</a:t>
             </a:r>
             <a:endParaRPr lang="en-US" sz="1000" dirty="0"/>
           </a:p>
@@ -19107,13 +19115,13 @@
       </p:sp>
       <p:sp>
         <p:nvSpPr>
-          <p:cNvPr id="55" name="Shape 53"/>
-          <p:cNvSpPr/>
-          <p:nvPr/>
-        </p:nvSpPr>
-        <p:spPr>
-          <a:xfrm>
-            <a:off x="454880" y="4663440"/>
+          <p:cNvPr id="55" name="Shape 3"/>
+          <p:cNvSpPr/>
+          <p:nvPr/>
+        </p:nvSpPr>
+        <p:spPr>
+          <a:xfrm>
+            <a:off x="454880" y="4114800"/>
             <a:ext cx="5532120" cy="548640"/>
           </a:xfrm>
           <a:prstGeom prst="rect">
@@ -19139,20 +19147,20 @@
       </p:sp>
       <p:sp>
         <p:nvSpPr>
-          <p:cNvPr id="56" name="Shape 54"/>
-          <p:cNvSpPr/>
-          <p:nvPr/>
-        </p:nvSpPr>
-        <p:spPr>
-          <a:xfrm>
-            <a:off x="454880" y="4663440"/>
+          <p:cNvPr id="56" name="Shape 4"/>
+          <p:cNvSpPr/>
+          <p:nvPr/>
+        </p:nvSpPr>
+        <p:spPr>
+          <a:xfrm>
+            <a:off x="454880" y="4114800"/>
             <a:ext cx="45720" cy="548640"/>
           </a:xfrm>
           <a:prstGeom prst="rect">
             <a:avLst/>
           </a:prstGeom>
           <a:solidFill>
-            <a:schemeClr val="bg2"/>
+            <a:srgbClr val="F59E0B"/>
           </a:solidFill>
           <a:ln w="12700">
             <a:noFill/>
@@ -19169,13 +19177,13 @@
       </p:sp>
       <p:sp>
         <p:nvSpPr>
-          <p:cNvPr id="57" name="Text 55"/>
-          <p:cNvSpPr/>
-          <p:nvPr/>
-        </p:nvSpPr>
-        <p:spPr>
-          <a:xfrm>
-            <a:off x="592040" y="4718304"/>
+          <p:cNvPr id="57" name="Text 5"/>
+          <p:cNvSpPr/>
+          <p:nvPr/>
+        </p:nvSpPr>
+        <p:spPr>
+          <a:xfrm>
+            <a:off x="592040" y="4169663"/>
             <a:ext cx="1828800" cy="182880"/>
           </a:xfrm>
           <a:prstGeom prst="rect">
@@ -19194,35 +19202,27 @@
             <a:r>
               <a:rPr lang="en-US" sz="700" b="1" kern="0" spc="200" dirty="0">
                 <a:solidFill>
-                  <a:schemeClr val="bg1">
-                    <a:lumMod val="50000"/>
-                  </a:schemeClr>
-                </a:solidFill>
-                <a:latin typeface="Calibri" pitchFamily="34" charset="0"/>
-                <a:ea typeface="Calibri" pitchFamily="34" charset="-122"/>
-                <a:cs typeface="Calibri" pitchFamily="34" charset="-120"/>
-              </a:rPr>
-              <a:t>Artifact</a:t>
-            </a:r>
-            <a:endParaRPr lang="en-US" sz="700" dirty="0">
-              <a:solidFill>
-                <a:schemeClr val="bg1">
-                  <a:lumMod val="50000"/>
-                </a:schemeClr>
-              </a:solidFill>
-            </a:endParaRPr>
-          </a:p>
-        </p:txBody>
-      </p:sp>
-      <p:sp>
-        <p:nvSpPr>
-          <p:cNvPr id="58" name="Text 56"/>
-          <p:cNvSpPr/>
-          <p:nvPr/>
-        </p:nvSpPr>
-        <p:spPr>
-          <a:xfrm>
-            <a:off x="592040" y="4928616"/>
+                  <a:srgbClr val="F59E0B"/>
+                </a:solidFill>
+                <a:latin typeface="Calibri" pitchFamily="34" charset="0"/>
+                <a:ea typeface="Calibri" pitchFamily="34" charset="-122"/>
+                <a:cs typeface="Calibri" pitchFamily="34" charset="-120"/>
+              </a:rPr>
+              <a:t>Skill — 03/06</a:t>
+            </a:r>
+            <a:endParaRPr lang="en-US" sz="700" dirty="0"/>
+          </a:p>
+        </p:txBody>
+      </p:sp>
+      <p:sp>
+        <p:nvSpPr>
+          <p:cNvPr id="58" name="Text 6"/>
+          <p:cNvSpPr/>
+          <p:nvPr/>
+        </p:nvSpPr>
+        <p:spPr>
+          <a:xfrm>
+            <a:off x="592040" y="4379976"/>
             <a:ext cx="4114800" cy="219456"/>
           </a:xfrm>
           <a:prstGeom prst="rect">
@@ -19247,7 +19247,7 @@
                 <a:ea typeface="Calibri" pitchFamily="34" charset="-122"/>
                 <a:cs typeface="Calibri" pitchFamily="34" charset="-120"/>
               </a:rPr>
-              <a:t>design-process-system.jsx</a:t>
+              <a:t>design-systems.md</a:t>
             </a:r>
             <a:endParaRPr lang="en-US" sz="1200" dirty="0"/>
           </a:p>
@@ -19255,14 +19255,14 @@
       </p:sp>
       <p:sp>
         <p:nvSpPr>
-          <p:cNvPr id="59" name="Text 57"/>
-          <p:cNvSpPr/>
-          <p:nvPr/>
-        </p:nvSpPr>
-        <p:spPr>
-          <a:xfrm>
-            <a:off x="4798280" y="4928616"/>
-            <a:ext cx="1051560" cy="219456"/>
+          <p:cNvPr id="59" name="Text 7"/>
+          <p:cNvSpPr/>
+          <p:nvPr/>
+        </p:nvSpPr>
+        <p:spPr>
+          <a:xfrm>
+            <a:off x="4336000" y="4379976"/>
+            <a:ext cx="1513840" cy="73152"/>
           </a:xfrm>
           <a:prstGeom prst="rect">
             <a:avLst/>
@@ -19286,7 +19286,7 @@
                 <a:ea typeface="Calibri" pitchFamily="34" charset="-122"/>
                 <a:cs typeface="Calibri" pitchFamily="34" charset="-120"/>
               </a:rPr>
-              <a:t>Phase explorer</a:t>
+              <a:t>Ideate + Deliver</a:t>
             </a:r>
             <a:endParaRPr lang="en-US" sz="1000" dirty="0"/>
           </a:p>
@@ -19294,13 +19294,13 @@
       </p:sp>
       <p:sp>
         <p:nvSpPr>
-          <p:cNvPr id="60" name="Shape 58"/>
-          <p:cNvSpPr/>
-          <p:nvPr/>
-        </p:nvSpPr>
-        <p:spPr>
-          <a:xfrm>
-            <a:off x="6215600" y="4663440"/>
+          <p:cNvPr id="60" name="Shape 8"/>
+          <p:cNvSpPr/>
+          <p:nvPr/>
+        </p:nvSpPr>
+        <p:spPr>
+          <a:xfrm>
+            <a:off x="6215600" y="4114800"/>
             <a:ext cx="5532120" cy="548640"/>
           </a:xfrm>
           <a:prstGeom prst="rect">
@@ -19326,13 +19326,13 @@
       </p:sp>
       <p:sp>
         <p:nvSpPr>
-          <p:cNvPr id="61" name="Shape 59"/>
-          <p:cNvSpPr/>
-          <p:nvPr/>
-        </p:nvSpPr>
-        <p:spPr>
-          <a:xfrm>
-            <a:off x="6215600" y="4663440"/>
+          <p:cNvPr id="61" name="Shape 9"/>
+          <p:cNvSpPr/>
+          <p:nvPr/>
+        </p:nvSpPr>
+        <p:spPr>
+          <a:xfrm>
+            <a:off x="6215600" y="4114800"/>
             <a:ext cx="45720" cy="548640"/>
           </a:xfrm>
           <a:prstGeom prst="rect">
@@ -19356,13 +19356,13 @@
       </p:sp>
       <p:sp>
         <p:nvSpPr>
-          <p:cNvPr id="62" name="Text 60"/>
-          <p:cNvSpPr/>
-          <p:nvPr/>
-        </p:nvSpPr>
-        <p:spPr>
-          <a:xfrm>
-            <a:off x="6352760" y="4718304"/>
+          <p:cNvPr id="62" name="Text 10"/>
+          <p:cNvSpPr/>
+          <p:nvPr/>
+        </p:nvSpPr>
+        <p:spPr>
+          <a:xfrm>
+            <a:off x="6352760" y="4169663"/>
             <a:ext cx="1828800" cy="182880"/>
           </a:xfrm>
           <a:prstGeom prst="rect">
@@ -19389,7 +19389,7 @@
                 <a:ea typeface="Calibri" pitchFamily="34" charset="-122"/>
                 <a:cs typeface="Calibri" pitchFamily="34" charset="-120"/>
               </a:rPr>
-              <a:t>Artifact</a:t>
+              <a:t>Skill — ALL</a:t>
             </a:r>
             <a:endParaRPr lang="en-US" sz="700" dirty="0">
               <a:solidFill>
@@ -19403,13 +19403,13 @@
       </p:sp>
       <p:sp>
         <p:nvSpPr>
-          <p:cNvPr id="63" name="Text 61"/>
-          <p:cNvSpPr/>
-          <p:nvPr/>
-        </p:nvSpPr>
-        <p:spPr>
-          <a:xfrm>
-            <a:off x="6352760" y="4928616"/>
+          <p:cNvPr id="63" name="Text 11"/>
+          <p:cNvSpPr/>
+          <p:nvPr/>
+        </p:nvSpPr>
+        <p:spPr>
+          <a:xfrm>
+            <a:off x="6352760" y="4379976"/>
             <a:ext cx="4114800" cy="219456"/>
           </a:xfrm>
           <a:prstGeom prst="rect">
@@ -19434,7 +19434,7 @@
                 <a:ea typeface="Calibri" pitchFamily="34" charset="-122"/>
                 <a:cs typeface="Calibri" pitchFamily="34" charset="-120"/>
               </a:rPr>
-              <a:t>design-tokens-system.jsx</a:t>
+              <a:t>skill-chaining.md</a:t>
             </a:r>
             <a:endParaRPr lang="en-US" sz="1200" dirty="0"/>
           </a:p>
@@ -19442,13 +19442,13 @@
       </p:sp>
       <p:sp>
         <p:nvSpPr>
-          <p:cNvPr id="64" name="Text 62"/>
-          <p:cNvSpPr/>
-          <p:nvPr/>
-        </p:nvSpPr>
-        <p:spPr>
-          <a:xfrm>
-            <a:off x="10559000" y="4928616"/>
+          <p:cNvPr id="64" name="Text 12"/>
+          <p:cNvSpPr/>
+          <p:nvPr/>
+        </p:nvSpPr>
+        <p:spPr>
+          <a:xfrm>
+            <a:off x="10559000" y="4379976"/>
             <a:ext cx="1051560" cy="219456"/>
           </a:xfrm>
           <a:prstGeom prst="rect">
@@ -19473,7 +19473,7 @@
                 <a:ea typeface="Calibri" pitchFamily="34" charset="-122"/>
                 <a:cs typeface="Calibri" pitchFamily="34" charset="-120"/>
               </a:rPr>
-              <a:t>Token builder</a:t>
+              <a:t>All phases</a:t>
             </a:r>
             <a:endParaRPr lang="en-US" sz="1000" dirty="0"/>
           </a:p>
@@ -19481,13 +19481,13 @@
       </p:sp>
       <p:sp>
         <p:nvSpPr>
-          <p:cNvPr id="65" name="Shape 63"/>
-          <p:cNvSpPr/>
-          <p:nvPr/>
-        </p:nvSpPr>
-        <p:spPr>
-          <a:xfrm>
-            <a:off x="454880" y="5321808"/>
+          <p:cNvPr id="65" name="Shape 3"/>
+          <p:cNvSpPr/>
+          <p:nvPr/>
+        </p:nvSpPr>
+        <p:spPr>
+          <a:xfrm>
+            <a:off x="454880" y="4663440"/>
             <a:ext cx="5532120" cy="548640"/>
           </a:xfrm>
           <a:prstGeom prst="rect">
@@ -19513,13 +19513,13 @@
       </p:sp>
       <p:sp>
         <p:nvSpPr>
-          <p:cNvPr id="66" name="Shape 64"/>
-          <p:cNvSpPr/>
-          <p:nvPr/>
-        </p:nvSpPr>
-        <p:spPr>
-          <a:xfrm>
-            <a:off x="454880" y="5321808"/>
+          <p:cNvPr id="66" name="Shape 4"/>
+          <p:cNvSpPr/>
+          <p:nvPr/>
+        </p:nvSpPr>
+        <p:spPr>
+          <a:xfrm>
+            <a:off x="454880" y="4663440"/>
             <a:ext cx="45720" cy="548640"/>
           </a:xfrm>
           <a:prstGeom prst="rect">
@@ -19543,13 +19543,13 @@
       </p:sp>
       <p:sp>
         <p:nvSpPr>
-          <p:cNvPr id="67" name="Text 65"/>
-          <p:cNvSpPr/>
-          <p:nvPr/>
-        </p:nvSpPr>
-        <p:spPr>
-          <a:xfrm>
-            <a:off x="592040" y="5376672"/>
+          <p:cNvPr id="67" name="Text 5"/>
+          <p:cNvSpPr/>
+          <p:nvPr/>
+        </p:nvSpPr>
+        <p:spPr>
+          <a:xfrm>
+            <a:off x="592040" y="4718303"/>
             <a:ext cx="1828800" cy="182880"/>
           </a:xfrm>
           <a:prstGeom prst="rect">
@@ -19576,7 +19576,7 @@
                 <a:ea typeface="Calibri" pitchFamily="34" charset="-122"/>
                 <a:cs typeface="Calibri" pitchFamily="34" charset="-120"/>
               </a:rPr>
-              <a:t>Artifact</a:t>
+              <a:t>Skill — ALL</a:t>
             </a:r>
             <a:endParaRPr lang="en-US" sz="700" dirty="0">
               <a:solidFill>
@@ -19590,13 +19590,13 @@
       </p:sp>
       <p:sp>
         <p:nvSpPr>
-          <p:cNvPr id="68" name="Text 66"/>
-          <p:cNvSpPr/>
-          <p:nvPr/>
-        </p:nvSpPr>
-        <p:spPr>
-          <a:xfrm>
-            <a:off x="592040" y="5586984"/>
+          <p:cNvPr id="68" name="Text 6"/>
+          <p:cNvSpPr/>
+          <p:nvPr/>
+        </p:nvSpPr>
+        <p:spPr>
+          <a:xfrm>
+            <a:off x="592040" y="4928616"/>
             <a:ext cx="4114800" cy="219456"/>
           </a:xfrm>
           <a:prstGeom prst="rect">
@@ -19621,7 +19621,7 @@
                 <a:ea typeface="Calibri" pitchFamily="34" charset="-122"/>
                 <a:cs typeface="Calibri" pitchFamily="34" charset="-120"/>
               </a:rPr>
-              <a:t>design-system-checklist.jsx</a:t>
+              <a:t>figma-playbook.md</a:t>
             </a:r>
             <a:endParaRPr lang="en-US" sz="1200" dirty="0"/>
           </a:p>
@@ -19629,14 +19629,14 @@
       </p:sp>
       <p:sp>
         <p:nvSpPr>
-          <p:cNvPr id="69" name="Text 67"/>
-          <p:cNvSpPr/>
-          <p:nvPr/>
-        </p:nvSpPr>
-        <p:spPr>
-          <a:xfrm>
-            <a:off x="4798280" y="5586984"/>
-            <a:ext cx="1051560" cy="219456"/>
+          <p:cNvPr id="69" name="Text 7"/>
+          <p:cNvSpPr/>
+          <p:nvPr/>
+        </p:nvSpPr>
+        <p:spPr>
+          <a:xfrm>
+            <a:off x="4336000" y="4928616"/>
+            <a:ext cx="1513840" cy="73152"/>
           </a:xfrm>
           <a:prstGeom prst="rect">
             <a:avLst/>
@@ -19660,7 +19660,7 @@
                 <a:ea typeface="Calibri" pitchFamily="34" charset="-122"/>
                 <a:cs typeface="Calibri" pitchFamily="34" charset="-120"/>
               </a:rPr>
-              <a:t>Audit tool</a:t>
+              <a:t>All phases</a:t>
             </a:r>
             <a:endParaRPr lang="en-US" sz="1000" dirty="0"/>
           </a:p>
@@ -19668,13 +19668,13 @@
       </p:sp>
       <p:sp>
         <p:nvSpPr>
-          <p:cNvPr id="70" name="Shape 68"/>
-          <p:cNvSpPr/>
-          <p:nvPr/>
-        </p:nvSpPr>
-        <p:spPr>
-          <a:xfrm>
-            <a:off x="6215600" y="5321808"/>
+          <p:cNvPr id="70" name="Shape 8"/>
+          <p:cNvSpPr/>
+          <p:nvPr/>
+        </p:nvSpPr>
+        <p:spPr>
+          <a:xfrm>
+            <a:off x="6215600" y="4663440"/>
             <a:ext cx="5532120" cy="548640"/>
           </a:xfrm>
           <a:prstGeom prst="rect">
@@ -19700,13 +19700,13 @@
       </p:sp>
       <p:sp>
         <p:nvSpPr>
-          <p:cNvPr id="71" name="Shape 69"/>
-          <p:cNvSpPr/>
-          <p:nvPr/>
-        </p:nvSpPr>
-        <p:spPr>
-          <a:xfrm>
-            <a:off x="6215600" y="5321808"/>
+          <p:cNvPr id="71" name="Shape 9"/>
+          <p:cNvSpPr/>
+          <p:nvPr/>
+        </p:nvSpPr>
+        <p:spPr>
+          <a:xfrm>
+            <a:off x="6215600" y="4663440"/>
             <a:ext cx="45720" cy="548640"/>
           </a:xfrm>
           <a:prstGeom prst="rect">
@@ -19730,13 +19730,13 @@
       </p:sp>
       <p:sp>
         <p:nvSpPr>
-          <p:cNvPr id="72" name="Text 70"/>
-          <p:cNvSpPr/>
-          <p:nvPr/>
-        </p:nvSpPr>
-        <p:spPr>
-          <a:xfrm>
-            <a:off x="6352760" y="5376672"/>
+          <p:cNvPr id="72" name="Text 10"/>
+          <p:cNvSpPr/>
+          <p:nvPr/>
+        </p:nvSpPr>
+        <p:spPr>
+          <a:xfrm>
+            <a:off x="6352760" y="4718303"/>
             <a:ext cx="1828800" cy="182880"/>
           </a:xfrm>
           <a:prstGeom prst="rect">
@@ -19763,7 +19763,7 @@
                 <a:ea typeface="Calibri" pitchFamily="34" charset="-122"/>
                 <a:cs typeface="Calibri" pitchFamily="34" charset="-120"/>
               </a:rPr>
-              <a:t>Artifact</a:t>
+              <a:t>Tool</a:t>
             </a:r>
             <a:endParaRPr lang="en-US" sz="700" dirty="0">
               <a:solidFill>
@@ -19777,13 +19777,13 @@
       </p:sp>
       <p:sp>
         <p:nvSpPr>
-          <p:cNvPr id="73" name="Text 71"/>
-          <p:cNvSpPr/>
-          <p:nvPr/>
-        </p:nvSpPr>
-        <p:spPr>
-          <a:xfrm>
-            <a:off x="6352760" y="5586984"/>
+          <p:cNvPr id="73" name="Text 11"/>
+          <p:cNvSpPr/>
+          <p:nvPr/>
+        </p:nvSpPr>
+        <p:spPr>
+          <a:xfrm>
+            <a:off x="6352760" y="4928616"/>
             <a:ext cx="4114800" cy="219456"/>
           </a:xfrm>
           <a:prstGeom prst="rect">
@@ -19808,7 +19808,7 @@
                 <a:ea typeface="Calibri" pitchFamily="34" charset="-122"/>
                 <a:cs typeface="Calibri" pitchFamily="34" charset="-120"/>
               </a:rPr>
-              <a:t>m3-token-reference.jsx</a:t>
+              <a:t>Design Process System</a:t>
             </a:r>
             <a:endParaRPr lang="en-US" sz="1200" dirty="0"/>
           </a:p>
@@ -19816,13 +19816,13 @@
       </p:sp>
       <p:sp>
         <p:nvSpPr>
-          <p:cNvPr id="74" name="Text 72"/>
-          <p:cNvSpPr/>
-          <p:nvPr/>
-        </p:nvSpPr>
-        <p:spPr>
-          <a:xfrm>
-            <a:off x="10559000" y="5586984"/>
+          <p:cNvPr id="74" name="Text 12"/>
+          <p:cNvSpPr/>
+          <p:nvPr/>
+        </p:nvSpPr>
+        <p:spPr>
+          <a:xfrm>
+            <a:off x="10559000" y="4928616"/>
             <a:ext cx="1051560" cy="219456"/>
           </a:xfrm>
           <a:prstGeom prst="rect">
@@ -19847,7 +19847,755 @@
                 <a:ea typeface="Calibri" pitchFamily="34" charset="-122"/>
                 <a:cs typeface="Calibri" pitchFamily="34" charset="-120"/>
               </a:rPr>
-              <a:t>M3 reference</a:t>
+              <a:t>Phase explorer</a:t>
+            </a:r>
+            <a:endParaRPr lang="en-US" sz="1000" dirty="0"/>
+          </a:p>
+        </p:txBody>
+      </p:sp>
+      <p:sp>
+        <p:nvSpPr>
+          <p:cNvPr id="75" name="Shape 3"/>
+          <p:cNvSpPr/>
+          <p:nvPr/>
+        </p:nvSpPr>
+        <p:spPr>
+          <a:xfrm>
+            <a:off x="454880" y="5212080"/>
+            <a:ext cx="5532120" cy="548640"/>
+          </a:xfrm>
+          <a:prstGeom prst="rect">
+            <a:avLst/>
+          </a:prstGeom>
+          <a:solidFill>
+            <a:srgbClr val="FFFFFF"/>
+          </a:solidFill>
+          <a:ln w="6350">
+            <a:solidFill>
+              <a:srgbClr val="E2E8F0"/>
+            </a:solidFill>
+            <a:prstDash val="solid"/>
+          </a:ln>
+        </p:spPr>
+        <p:txBody>
+          <a:bodyPr/>
+          <a:lstStyle/>
+          <a:p>
+            <a:endParaRPr lang="en-US"/>
+          </a:p>
+        </p:txBody>
+      </p:sp>
+      <p:sp>
+        <p:nvSpPr>
+          <p:cNvPr id="76" name="Shape 4"/>
+          <p:cNvSpPr/>
+          <p:nvPr/>
+        </p:nvSpPr>
+        <p:spPr>
+          <a:xfrm>
+            <a:off x="454880" y="5212080"/>
+            <a:ext cx="45720" cy="548640"/>
+          </a:xfrm>
+          <a:prstGeom prst="rect">
+            <a:avLst/>
+          </a:prstGeom>
+          <a:solidFill>
+            <a:schemeClr val="bg2"/>
+          </a:solidFill>
+          <a:ln w="12700">
+            <a:noFill/>
+            <a:prstDash val="solid"/>
+          </a:ln>
+        </p:spPr>
+        <p:txBody>
+          <a:bodyPr/>
+          <a:lstStyle/>
+          <a:p>
+            <a:endParaRPr lang="en-US"/>
+          </a:p>
+        </p:txBody>
+      </p:sp>
+      <p:sp>
+        <p:nvSpPr>
+          <p:cNvPr id="77" name="Text 5"/>
+          <p:cNvSpPr/>
+          <p:nvPr/>
+        </p:nvSpPr>
+        <p:spPr>
+          <a:xfrm>
+            <a:off x="592040" y="5266944"/>
+            <a:ext cx="1828800" cy="182880"/>
+          </a:xfrm>
+          <a:prstGeom prst="rect">
+            <a:avLst/>
+          </a:prstGeom>
+          <a:noFill/>
+          <a:ln/>
+        </p:spPr>
+        <p:txBody>
+          <a:bodyPr wrap="square" lIns="0" tIns="0" rIns="0" bIns="0" rtlCol="0" anchor="ctr"/>
+          <a:lstStyle/>
+          <a:p>
+            <a:pPr marL="0" indent="0">
+              <a:buNone/>
+            </a:pPr>
+            <a:r>
+              <a:rPr lang="en-US" sz="700" b="1" kern="0" spc="200" dirty="0">
+                <a:solidFill>
+                  <a:schemeClr val="bg1">
+                    <a:lumMod val="50000"/>
+                  </a:schemeClr>
+                </a:solidFill>
+                <a:latin typeface="Calibri" pitchFamily="34" charset="0"/>
+                <a:ea typeface="Calibri" pitchFamily="34" charset="-122"/>
+                <a:cs typeface="Calibri" pitchFamily="34" charset="-120"/>
+              </a:rPr>
+              <a:t>Tool</a:t>
+            </a:r>
+            <a:endParaRPr lang="en-US" sz="700" dirty="0">
+              <a:solidFill>
+                <a:schemeClr val="bg1">
+                  <a:lumMod val="50000"/>
+                </a:schemeClr>
+              </a:solidFill>
+            </a:endParaRPr>
+          </a:p>
+        </p:txBody>
+      </p:sp>
+      <p:sp>
+        <p:nvSpPr>
+          <p:cNvPr id="78" name="Text 6"/>
+          <p:cNvSpPr/>
+          <p:nvPr/>
+        </p:nvSpPr>
+        <p:spPr>
+          <a:xfrm>
+            <a:off x="592040" y="5477256"/>
+            <a:ext cx="4114800" cy="219456"/>
+          </a:xfrm>
+          <a:prstGeom prst="rect">
+            <a:avLst/>
+          </a:prstGeom>
+          <a:noFill/>
+          <a:ln/>
+        </p:spPr>
+        <p:txBody>
+          <a:bodyPr wrap="square" lIns="0" tIns="0" rIns="0" bIns="0" rtlCol="0" anchor="ctr"/>
+          <a:lstStyle/>
+          <a:p>
+            <a:pPr marL="0" indent="0">
+              <a:buNone/>
+            </a:pPr>
+            <a:r>
+              <a:rPr lang="en-US" sz="1200" dirty="0">
+                <a:solidFill>
+                  <a:srgbClr val="0F172A"/>
+                </a:solidFill>
+                <a:latin typeface="Calibri" pitchFamily="34" charset="0"/>
+                <a:ea typeface="Calibri" pitchFamily="34" charset="-122"/>
+                <a:cs typeface="Calibri" pitchFamily="34" charset="-120"/>
+              </a:rPr>
+              <a:t>AI Brief Generator</a:t>
+            </a:r>
+            <a:endParaRPr lang="en-US" sz="1200" dirty="0"/>
+          </a:p>
+        </p:txBody>
+      </p:sp>
+      <p:sp>
+        <p:nvSpPr>
+          <p:cNvPr id="79" name="Text 7"/>
+          <p:cNvSpPr/>
+          <p:nvPr/>
+        </p:nvSpPr>
+        <p:spPr>
+          <a:xfrm>
+            <a:off x="4336000" y="5477256"/>
+            <a:ext cx="1513840" cy="73152"/>
+          </a:xfrm>
+          <a:prstGeom prst="rect">
+            <a:avLst/>
+          </a:prstGeom>
+          <a:noFill/>
+          <a:ln/>
+        </p:spPr>
+        <p:txBody>
+          <a:bodyPr wrap="square" lIns="0" tIns="0" rIns="0" bIns="0" rtlCol="0" anchor="ctr"/>
+          <a:lstStyle/>
+          <a:p>
+            <a:pPr marL="0" indent="0" algn="r">
+              <a:buNone/>
+            </a:pPr>
+            <a:r>
+              <a:rPr lang="en-US" sz="1000" dirty="0">
+                <a:solidFill>
+                  <a:srgbClr val="64748B"/>
+                </a:solidFill>
+                <a:latin typeface="Calibri" pitchFamily="34" charset="0"/>
+                <a:ea typeface="Calibri" pitchFamily="34" charset="-122"/>
+                <a:cs typeface="Calibri" pitchFamily="34" charset="-120"/>
+              </a:rPr>
+              <a:t>Project kickoff</a:t>
+            </a:r>
+            <a:endParaRPr lang="en-US" sz="1000" dirty="0"/>
+          </a:p>
+        </p:txBody>
+      </p:sp>
+      <p:sp>
+        <p:nvSpPr>
+          <p:cNvPr id="80" name="Shape 8"/>
+          <p:cNvSpPr/>
+          <p:nvPr/>
+        </p:nvSpPr>
+        <p:spPr>
+          <a:xfrm>
+            <a:off x="6215600" y="5212080"/>
+            <a:ext cx="5532120" cy="548640"/>
+          </a:xfrm>
+          <a:prstGeom prst="rect">
+            <a:avLst/>
+          </a:prstGeom>
+          <a:solidFill>
+            <a:srgbClr val="FFFFFF"/>
+          </a:solidFill>
+          <a:ln w="6350">
+            <a:solidFill>
+              <a:srgbClr val="E2E8F0"/>
+            </a:solidFill>
+            <a:prstDash val="solid"/>
+          </a:ln>
+        </p:spPr>
+        <p:txBody>
+          <a:bodyPr/>
+          <a:lstStyle/>
+          <a:p>
+            <a:endParaRPr lang="en-US"/>
+          </a:p>
+        </p:txBody>
+      </p:sp>
+      <p:sp>
+        <p:nvSpPr>
+          <p:cNvPr id="81" name="Shape 9"/>
+          <p:cNvSpPr/>
+          <p:nvPr/>
+        </p:nvSpPr>
+        <p:spPr>
+          <a:xfrm>
+            <a:off x="6215600" y="5212080"/>
+            <a:ext cx="45720" cy="548640"/>
+          </a:xfrm>
+          <a:prstGeom prst="rect">
+            <a:avLst/>
+          </a:prstGeom>
+          <a:solidFill>
+            <a:schemeClr val="bg2"/>
+          </a:solidFill>
+          <a:ln w="12700">
+            <a:noFill/>
+            <a:prstDash val="solid"/>
+          </a:ln>
+        </p:spPr>
+        <p:txBody>
+          <a:bodyPr/>
+          <a:lstStyle/>
+          <a:p>
+            <a:endParaRPr lang="en-US"/>
+          </a:p>
+        </p:txBody>
+      </p:sp>
+      <p:sp>
+        <p:nvSpPr>
+          <p:cNvPr id="82" name="Text 10"/>
+          <p:cNvSpPr/>
+          <p:nvPr/>
+        </p:nvSpPr>
+        <p:spPr>
+          <a:xfrm>
+            <a:off x="6352760" y="5266944"/>
+            <a:ext cx="1828800" cy="182880"/>
+          </a:xfrm>
+          <a:prstGeom prst="rect">
+            <a:avLst/>
+          </a:prstGeom>
+          <a:noFill/>
+          <a:ln/>
+        </p:spPr>
+        <p:txBody>
+          <a:bodyPr wrap="square" lIns="0" tIns="0" rIns="0" bIns="0" rtlCol="0" anchor="ctr"/>
+          <a:lstStyle/>
+          <a:p>
+            <a:pPr marL="0" indent="0">
+              <a:buNone/>
+            </a:pPr>
+            <a:r>
+              <a:rPr lang="en-US" sz="700" b="1" kern="0" spc="200" dirty="0">
+                <a:solidFill>
+                  <a:schemeClr val="bg1">
+                    <a:lumMod val="50000"/>
+                  </a:schemeClr>
+                </a:solidFill>
+                <a:latin typeface="Calibri" pitchFamily="34" charset="0"/>
+                <a:ea typeface="Calibri" pitchFamily="34" charset="-122"/>
+                <a:cs typeface="Calibri" pitchFamily="34" charset="-120"/>
+              </a:rPr>
+              <a:t>Tool</a:t>
+            </a:r>
+            <a:endParaRPr lang="en-US" sz="700" dirty="0">
+              <a:solidFill>
+                <a:schemeClr val="bg1">
+                  <a:lumMod val="50000"/>
+                </a:schemeClr>
+              </a:solidFill>
+            </a:endParaRPr>
+          </a:p>
+        </p:txBody>
+      </p:sp>
+      <p:sp>
+        <p:nvSpPr>
+          <p:cNvPr id="83" name="Text 11"/>
+          <p:cNvSpPr/>
+          <p:nvPr/>
+        </p:nvSpPr>
+        <p:spPr>
+          <a:xfrm>
+            <a:off x="6352760" y="5477256"/>
+            <a:ext cx="4114800" cy="219456"/>
+          </a:xfrm>
+          <a:prstGeom prst="rect">
+            <a:avLst/>
+          </a:prstGeom>
+          <a:noFill/>
+          <a:ln/>
+        </p:spPr>
+        <p:txBody>
+          <a:bodyPr wrap="square" lIns="0" tIns="0" rIns="0" bIns="0" rtlCol="0" anchor="ctr"/>
+          <a:lstStyle/>
+          <a:p>
+            <a:pPr marL="0" indent="0">
+              <a:buNone/>
+            </a:pPr>
+            <a:r>
+              <a:rPr lang="en-US" sz="1200" dirty="0">
+                <a:solidFill>
+                  <a:srgbClr val="0F172A"/>
+                </a:solidFill>
+                <a:latin typeface="Calibri" pitchFamily="34" charset="0"/>
+                <a:ea typeface="Calibri" pitchFamily="34" charset="-122"/>
+                <a:cs typeface="Calibri" pitchFamily="34" charset="-120"/>
+              </a:rPr>
+              <a:t>Brand Style Builder</a:t>
+            </a:r>
+            <a:endParaRPr lang="en-US" sz="1200" dirty="0"/>
+          </a:p>
+        </p:txBody>
+      </p:sp>
+      <p:sp>
+        <p:nvSpPr>
+          <p:cNvPr id="84" name="Text 12"/>
+          <p:cNvSpPr/>
+          <p:nvPr/>
+        </p:nvSpPr>
+        <p:spPr>
+          <a:xfrm>
+            <a:off x="10559000" y="5477256"/>
+            <a:ext cx="1051560" cy="219456"/>
+          </a:xfrm>
+          <a:prstGeom prst="rect">
+            <a:avLst/>
+          </a:prstGeom>
+          <a:noFill/>
+          <a:ln/>
+        </p:spPr>
+        <p:txBody>
+          <a:bodyPr wrap="square" lIns="0" tIns="0" rIns="0" bIns="0" rtlCol="0" anchor="ctr"/>
+          <a:lstStyle/>
+          <a:p>
+            <a:pPr marL="0" indent="0" algn="r">
+              <a:buNone/>
+            </a:pPr>
+            <a:r>
+              <a:rPr lang="en-US" sz="1000" dirty="0">
+                <a:solidFill>
+                  <a:srgbClr val="64748B"/>
+                </a:solidFill>
+                <a:latin typeface="Calibri" pitchFamily="34" charset="0"/>
+                <a:ea typeface="Calibri" pitchFamily="34" charset="-122"/>
+                <a:cs typeface="Calibri" pitchFamily="34" charset="-120"/>
+              </a:rPr>
+              <a:t>Token builder</a:t>
+            </a:r>
+            <a:endParaRPr lang="en-US" sz="1000" dirty="0"/>
+          </a:p>
+        </p:txBody>
+      </p:sp>
+      <p:sp>
+        <p:nvSpPr>
+          <p:cNvPr id="85" name="Shape 3"/>
+          <p:cNvSpPr/>
+          <p:nvPr/>
+        </p:nvSpPr>
+        <p:spPr>
+          <a:xfrm>
+            <a:off x="454880" y="5760720"/>
+            <a:ext cx="5532120" cy="548640"/>
+          </a:xfrm>
+          <a:prstGeom prst="rect">
+            <a:avLst/>
+          </a:prstGeom>
+          <a:solidFill>
+            <a:srgbClr val="FFFFFF"/>
+          </a:solidFill>
+          <a:ln w="6350">
+            <a:solidFill>
+              <a:srgbClr val="E2E8F0"/>
+            </a:solidFill>
+            <a:prstDash val="solid"/>
+          </a:ln>
+        </p:spPr>
+        <p:txBody>
+          <a:bodyPr/>
+          <a:lstStyle/>
+          <a:p>
+            <a:endParaRPr lang="en-US"/>
+          </a:p>
+        </p:txBody>
+      </p:sp>
+      <p:sp>
+        <p:nvSpPr>
+          <p:cNvPr id="86" name="Shape 4"/>
+          <p:cNvSpPr/>
+          <p:nvPr/>
+        </p:nvSpPr>
+        <p:spPr>
+          <a:xfrm>
+            <a:off x="454880" y="5760720"/>
+            <a:ext cx="45720" cy="548640"/>
+          </a:xfrm>
+          <a:prstGeom prst="rect">
+            <a:avLst/>
+          </a:prstGeom>
+          <a:solidFill>
+            <a:schemeClr val="bg2"/>
+          </a:solidFill>
+          <a:ln w="12700">
+            <a:noFill/>
+            <a:prstDash val="solid"/>
+          </a:ln>
+        </p:spPr>
+        <p:txBody>
+          <a:bodyPr/>
+          <a:lstStyle/>
+          <a:p>
+            <a:endParaRPr lang="en-US"/>
+          </a:p>
+        </p:txBody>
+      </p:sp>
+      <p:sp>
+        <p:nvSpPr>
+          <p:cNvPr id="87" name="Text 5"/>
+          <p:cNvSpPr/>
+          <p:nvPr/>
+        </p:nvSpPr>
+        <p:spPr>
+          <a:xfrm>
+            <a:off x="592040" y="5815583"/>
+            <a:ext cx="1828800" cy="182880"/>
+          </a:xfrm>
+          <a:prstGeom prst="rect">
+            <a:avLst/>
+          </a:prstGeom>
+          <a:noFill/>
+          <a:ln/>
+        </p:spPr>
+        <p:txBody>
+          <a:bodyPr wrap="square" lIns="0" tIns="0" rIns="0" bIns="0" rtlCol="0" anchor="ctr"/>
+          <a:lstStyle/>
+          <a:p>
+            <a:pPr marL="0" indent="0">
+              <a:buNone/>
+            </a:pPr>
+            <a:r>
+              <a:rPr lang="en-US" sz="700" b="1" kern="0" spc="200" dirty="0">
+                <a:solidFill>
+                  <a:schemeClr val="bg1">
+                    <a:lumMod val="50000"/>
+                  </a:schemeClr>
+                </a:solidFill>
+                <a:latin typeface="Calibri" pitchFamily="34" charset="0"/>
+                <a:ea typeface="Calibri" pitchFamily="34" charset="-122"/>
+                <a:cs typeface="Calibri" pitchFamily="34" charset="-120"/>
+              </a:rPr>
+              <a:t>Tool</a:t>
+            </a:r>
+            <a:endParaRPr lang="en-US" sz="700" dirty="0">
+              <a:solidFill>
+                <a:schemeClr val="bg1">
+                  <a:lumMod val="50000"/>
+                </a:schemeClr>
+              </a:solidFill>
+            </a:endParaRPr>
+          </a:p>
+        </p:txBody>
+      </p:sp>
+      <p:sp>
+        <p:nvSpPr>
+          <p:cNvPr id="88" name="Text 6"/>
+          <p:cNvSpPr/>
+          <p:nvPr/>
+        </p:nvSpPr>
+        <p:spPr>
+          <a:xfrm>
+            <a:off x="592040" y="6025896"/>
+            <a:ext cx="4114800" cy="219456"/>
+          </a:xfrm>
+          <a:prstGeom prst="rect">
+            <a:avLst/>
+          </a:prstGeom>
+          <a:noFill/>
+          <a:ln/>
+        </p:spPr>
+        <p:txBody>
+          <a:bodyPr wrap="square" lIns="0" tIns="0" rIns="0" bIns="0" rtlCol="0" anchor="ctr"/>
+          <a:lstStyle/>
+          <a:p>
+            <a:pPr marL="0" indent="0">
+              <a:buNone/>
+            </a:pPr>
+            <a:r>
+              <a:rPr lang="en-US" sz="1200" dirty="0">
+                <a:solidFill>
+                  <a:srgbClr val="0F172A"/>
+                </a:solidFill>
+                <a:latin typeface="Calibri" pitchFamily="34" charset="0"/>
+                <a:ea typeface="Calibri" pitchFamily="34" charset="-122"/>
+                <a:cs typeface="Calibri" pitchFamily="34" charset="-120"/>
+              </a:rPr>
+              <a:t>Design System Audit</a:t>
+            </a:r>
+            <a:endParaRPr lang="en-US" sz="1200" dirty="0"/>
+          </a:p>
+        </p:txBody>
+      </p:sp>
+      <p:sp>
+        <p:nvSpPr>
+          <p:cNvPr id="89" name="Text 7"/>
+          <p:cNvSpPr/>
+          <p:nvPr/>
+        </p:nvSpPr>
+        <p:spPr>
+          <a:xfrm>
+            <a:off x="4336000" y="6025896"/>
+            <a:ext cx="1513840" cy="73152"/>
+          </a:xfrm>
+          <a:prstGeom prst="rect">
+            <a:avLst/>
+          </a:prstGeom>
+          <a:noFill/>
+          <a:ln/>
+        </p:spPr>
+        <p:txBody>
+          <a:bodyPr wrap="square" lIns="0" tIns="0" rIns="0" bIns="0" rtlCol="0" anchor="ctr"/>
+          <a:lstStyle/>
+          <a:p>
+            <a:pPr marL="0" indent="0" algn="r">
+              <a:buNone/>
+            </a:pPr>
+            <a:r>
+              <a:rPr lang="en-US" sz="1000" dirty="0">
+                <a:solidFill>
+                  <a:srgbClr val="64748B"/>
+                </a:solidFill>
+                <a:latin typeface="Calibri" pitchFamily="34" charset="0"/>
+                <a:ea typeface="Calibri" pitchFamily="34" charset="-122"/>
+                <a:cs typeface="Calibri" pitchFamily="34" charset="-120"/>
+              </a:rPr>
+              <a:t>Audit tool</a:t>
+            </a:r>
+            <a:endParaRPr lang="en-US" sz="1000" dirty="0"/>
+          </a:p>
+        </p:txBody>
+      </p:sp>
+      <p:sp>
+        <p:nvSpPr>
+          <p:cNvPr id="90" name="Shape 8"/>
+          <p:cNvSpPr/>
+          <p:nvPr/>
+        </p:nvSpPr>
+        <p:spPr>
+          <a:xfrm>
+            <a:off x="6215600" y="5760720"/>
+            <a:ext cx="5532120" cy="548640"/>
+          </a:xfrm>
+          <a:prstGeom prst="rect">
+            <a:avLst/>
+          </a:prstGeom>
+          <a:solidFill>
+            <a:srgbClr val="FFFFFF"/>
+          </a:solidFill>
+          <a:ln w="6350">
+            <a:solidFill>
+              <a:srgbClr val="E2E8F0"/>
+            </a:solidFill>
+            <a:prstDash val="solid"/>
+          </a:ln>
+        </p:spPr>
+        <p:txBody>
+          <a:bodyPr/>
+          <a:lstStyle/>
+          <a:p>
+            <a:endParaRPr lang="en-US"/>
+          </a:p>
+        </p:txBody>
+      </p:sp>
+      <p:sp>
+        <p:nvSpPr>
+          <p:cNvPr id="91" name="Shape 9"/>
+          <p:cNvSpPr/>
+          <p:nvPr/>
+        </p:nvSpPr>
+        <p:spPr>
+          <a:xfrm>
+            <a:off x="6215600" y="5760720"/>
+            <a:ext cx="45720" cy="548640"/>
+          </a:xfrm>
+          <a:prstGeom prst="rect">
+            <a:avLst/>
+          </a:prstGeom>
+          <a:solidFill>
+            <a:schemeClr val="bg2"/>
+          </a:solidFill>
+          <a:ln w="12700">
+            <a:noFill/>
+            <a:prstDash val="solid"/>
+          </a:ln>
+        </p:spPr>
+        <p:txBody>
+          <a:bodyPr/>
+          <a:lstStyle/>
+          <a:p>
+            <a:endParaRPr lang="en-US"/>
+          </a:p>
+        </p:txBody>
+      </p:sp>
+      <p:sp>
+        <p:nvSpPr>
+          <p:cNvPr id="92" name="Text 10"/>
+          <p:cNvSpPr/>
+          <p:nvPr/>
+        </p:nvSpPr>
+        <p:spPr>
+          <a:xfrm>
+            <a:off x="6352760" y="5815583"/>
+            <a:ext cx="1828800" cy="182880"/>
+          </a:xfrm>
+          <a:prstGeom prst="rect">
+            <a:avLst/>
+          </a:prstGeom>
+          <a:noFill/>
+          <a:ln/>
+        </p:spPr>
+        <p:txBody>
+          <a:bodyPr wrap="square" lIns="0" tIns="0" rIns="0" bIns="0" rtlCol="0" anchor="ctr"/>
+          <a:lstStyle/>
+          <a:p>
+            <a:pPr marL="0" indent="0">
+              <a:buNone/>
+            </a:pPr>
+            <a:r>
+              <a:rPr lang="en-US" sz="700" b="1" kern="0" spc="200" dirty="0">
+                <a:solidFill>
+                  <a:schemeClr val="bg1">
+                    <a:lumMod val="50000"/>
+                  </a:schemeClr>
+                </a:solidFill>
+                <a:latin typeface="Calibri" pitchFamily="34" charset="0"/>
+                <a:ea typeface="Calibri" pitchFamily="34" charset="-122"/>
+                <a:cs typeface="Calibri" pitchFamily="34" charset="-120"/>
+              </a:rPr>
+              <a:t>GitHub</a:t>
+            </a:r>
+            <a:endParaRPr lang="en-US" sz="700" dirty="0">
+              <a:solidFill>
+                <a:schemeClr val="bg1">
+                  <a:lumMod val="50000"/>
+                </a:schemeClr>
+              </a:solidFill>
+            </a:endParaRPr>
+          </a:p>
+        </p:txBody>
+      </p:sp>
+      <p:sp>
+        <p:nvSpPr>
+          <p:cNvPr id="93" name="Text 11"/>
+          <p:cNvSpPr/>
+          <p:nvPr/>
+        </p:nvSpPr>
+        <p:spPr>
+          <a:xfrm>
+            <a:off x="6352760" y="6025896"/>
+            <a:ext cx="4114800" cy="219456"/>
+          </a:xfrm>
+          <a:prstGeom prst="rect">
+            <a:avLst/>
+          </a:prstGeom>
+          <a:noFill/>
+          <a:ln/>
+        </p:spPr>
+        <p:txBody>
+          <a:bodyPr wrap="square" lIns="0" tIns="0" rIns="0" bIns="0" rtlCol="0" anchor="ctr"/>
+          <a:lstStyle/>
+          <a:p>
+            <a:pPr marL="0" indent="0">
+              <a:buNone/>
+            </a:pPr>
+            <a:r>
+              <a:rPr lang="en-US" sz="1200" dirty="0">
+                <a:solidFill>
+                  <a:srgbClr val="0F172A"/>
+                </a:solidFill>
+                <a:latin typeface="Calibri" pitchFamily="34" charset="0"/>
+                <a:ea typeface="Calibri" pitchFamily="34" charset="-122"/>
+                <a:cs typeface="Calibri" pitchFamily="34" charset="-120"/>
+              </a:rPr>
+              <a:t>github.com/quinrobinson/Agentic-Product-Design-Framework</a:t>
+            </a:r>
+            <a:endParaRPr lang="en-US" sz="1200" dirty="0"/>
+          </a:p>
+        </p:txBody>
+      </p:sp>
+      <p:sp>
+        <p:nvSpPr>
+          <p:cNvPr id="94" name="Text 12"/>
+          <p:cNvSpPr/>
+          <p:nvPr/>
+        </p:nvSpPr>
+        <p:spPr>
+          <a:xfrm>
+            <a:off x="10559000" y="6025896"/>
+            <a:ext cx="1051560" cy="219456"/>
+          </a:xfrm>
+          <a:prstGeom prst="rect">
+            <a:avLst/>
+          </a:prstGeom>
+          <a:noFill/>
+          <a:ln/>
+        </p:spPr>
+        <p:txBody>
+          <a:bodyPr wrap="square" lIns="0" tIns="0" rIns="0" bIns="0" rtlCol="0" anchor="ctr"/>
+          <a:lstStyle/>
+          <a:p>
+            <a:pPr marL="0" indent="0" algn="r">
+              <a:buNone/>
+            </a:pPr>
+            <a:r>
+              <a:rPr lang="en-US" sz="1000" dirty="0">
+                <a:solidFill>
+                  <a:srgbClr val="64748B"/>
+                </a:solidFill>
+                <a:latin typeface="Calibri" pitchFamily="34" charset="0"/>
+                <a:ea typeface="Calibri" pitchFamily="34" charset="-122"/>
+                <a:cs typeface="Calibri" pitchFamily="34" charset="-120"/>
+              </a:rPr>
+              <a:t>Repo</a:t>
             </a:r>
             <a:endParaRPr lang="en-US" sz="1000" dirty="0"/>
           </a:p>
@@ -19894,7 +20642,7 @@
         </p:nvSpPr>
         <p:spPr>
           <a:xfrm>
-            <a:off x="513080" y="934720"/>
+            <a:off x="513080" y="403376"/>
             <a:ext cx="7315200" cy="1874520"/>
           </a:xfrm>
           <a:prstGeom prst="rect">
@@ -19919,27 +20667,25 @@
                 <a:ea typeface="Calibri" pitchFamily="34" charset="-122"/>
                 <a:cs typeface="Calibri" pitchFamily="34" charset="-120"/>
               </a:rPr>
-              <a:t>AI x UX</a:t>
+              <a:t>Agentic Product</a:t>
+            </a:r>
+            <a:r>
+              <a:rPr lang="en-US" sz="5600" dirty="0"/>
+              <a:t> </a:t>
+            </a:r>
+            <a:r>
+              <a:rPr lang="en-US" sz="5600" b="1" dirty="0">
+                <a:solidFill>
+                  <a:srgbClr val="FFFFFF"/>
+                </a:solidFill>
+                <a:latin typeface="Calibri" pitchFamily="34" charset="0"/>
+                <a:ea typeface="Calibri" pitchFamily="34" charset="-122"/>
+                <a:cs typeface="Calibri" pitchFamily="34" charset="-120"/>
+              </a:rPr>
+              <a:t>Design Framework</a:t>
             </a:r>
             <a:endParaRPr lang="en-US" sz="5600" dirty="0"/>
           </a:p>
-          <a:p>
-            <a:pPr marL="0" indent="0">
-              <a:buNone/>
-            </a:pPr>
-            <a:r>
-              <a:rPr lang="en-US" sz="5600" b="1" dirty="0">
-                <a:solidFill>
-                  <a:srgbClr val="FFFFFF"/>
-                </a:solidFill>
-                <a:latin typeface="Calibri" pitchFamily="34" charset="0"/>
-                <a:ea typeface="Calibri" pitchFamily="34" charset="-122"/>
-                <a:cs typeface="Calibri" pitchFamily="34" charset="-120"/>
-              </a:rPr>
-              <a:t>Design Framework</a:t>
-            </a:r>
-            <a:endParaRPr lang="en-US" sz="5600" dirty="0"/>
-          </a:p>
         </p:txBody>
       </p:sp>
       <p:sp>
@@ -19950,7 +20696,7 @@
         </p:nvSpPr>
         <p:spPr>
           <a:xfrm>
-            <a:off x="640080" y="2918968"/>
+            <a:off x="640080" y="2387624"/>
             <a:ext cx="1097280" cy="45720"/>
           </a:xfrm>
           <a:prstGeom prst="rect">
@@ -19982,7 +20728,7 @@
         </p:nvSpPr>
         <p:spPr>
           <a:xfrm>
-            <a:off x="640080" y="4025392"/>
+            <a:off x="640080" y="3054580"/>
             <a:ext cx="9144000" cy="201168"/>
           </a:xfrm>
           <a:prstGeom prst="rect">
@@ -20007,6 +20753,84 @@
                 <a:ea typeface="Calibri" pitchFamily="34" charset="-122"/>
                 <a:cs typeface="Calibri" pitchFamily="34" charset="-120"/>
               </a:rPr>
+              <a:t>LIVE SITE</a:t>
+            </a:r>
+            <a:endParaRPr lang="en-US" sz="900" dirty="0"/>
+          </a:p>
+        </p:txBody>
+      </p:sp>
+      <p:sp>
+        <p:nvSpPr>
+          <p:cNvPr id="6" name="Text 4"/>
+          <p:cNvSpPr/>
+          <p:nvPr/>
+        </p:nvSpPr>
+        <p:spPr>
+          <a:xfrm>
+            <a:off x="640080" y="3237460"/>
+            <a:ext cx="8229600" cy="256032"/>
+          </a:xfrm>
+          <a:prstGeom prst="rect">
+            <a:avLst/>
+          </a:prstGeom>
+          <a:noFill/>
+          <a:ln/>
+        </p:spPr>
+        <p:txBody>
+          <a:bodyPr wrap="square" lIns="0" tIns="0" rIns="0" bIns="0" rtlCol="0" anchor="ctr"/>
+          <a:lstStyle/>
+          <a:p>
+            <a:pPr marL="0" indent="0">
+              <a:buNone/>
+            </a:pPr>
+            <a:r>
+              <a:rPr lang="en-US" sz="1300" dirty="0">
+                <a:solidFill>
+                  <a:srgbClr val="E2E8F0"/>
+                </a:solidFill>
+                <a:latin typeface="Calibri" pitchFamily="34" charset="0"/>
+                <a:ea typeface="Calibri" pitchFamily="34" charset="-122"/>
+                <a:cs typeface="Calibri" pitchFamily="34" charset="-120"/>
+              </a:rPr>
+              <a:t>quinrobinson.github.io/Agentic-Product-Design-Framework</a:t>
+            </a:r>
+            <a:endParaRPr lang="en-US" sz="1300" dirty="0"/>
+          </a:p>
+        </p:txBody>
+      </p:sp>
+      <p:sp>
+        <p:nvSpPr>
+          <p:cNvPr id="7" name="Text 5"/>
+          <p:cNvSpPr/>
+          <p:nvPr/>
+        </p:nvSpPr>
+        <p:spPr>
+          <a:xfrm>
+            <a:off x="640080" y="3648940"/>
+            <a:ext cx="9144000" cy="201168"/>
+          </a:xfrm>
+          <a:prstGeom prst="rect">
+            <a:avLst/>
+          </a:prstGeom>
+          <a:noFill/>
+          <a:ln/>
+        </p:spPr>
+        <p:txBody>
+          <a:bodyPr wrap="square" lIns="0" tIns="0" rIns="0" bIns="0" rtlCol="0" anchor="ctr"/>
+          <a:lstStyle/>
+          <a:p>
+            <a:pPr marL="0" indent="0">
+              <a:buNone/>
+            </a:pPr>
+            <a:r>
+              <a:rPr lang="en-US" sz="900" b="1" kern="0" spc="300" dirty="0">
+                <a:solidFill>
+                  <a:srgbClr val="22C55E"/>
+                </a:solidFill>
+                <a:latin typeface="Calibri" pitchFamily="34" charset="0"/>
+                <a:ea typeface="Calibri" pitchFamily="34" charset="-122"/>
+                <a:cs typeface="Calibri" pitchFamily="34" charset="-120"/>
+              </a:rPr>
               <a:t>FIGMA TEMPLATE</a:t>
             </a:r>
             <a:endParaRPr lang="en-US" sz="900" dirty="0"/>
@@ -20015,13 +20839,13 @@
       </p:sp>
       <p:sp>
         <p:nvSpPr>
-          <p:cNvPr id="6" name="Text 4"/>
-          <p:cNvSpPr/>
-          <p:nvPr/>
-        </p:nvSpPr>
-        <p:spPr>
-          <a:xfrm>
-            <a:off x="640080" y="4226560"/>
+          <p:cNvPr id="8" name="Text 6"/>
+          <p:cNvSpPr/>
+          <p:nvPr/>
+        </p:nvSpPr>
+        <p:spPr>
+          <a:xfrm>
+            <a:off x="640080" y="3831820"/>
             <a:ext cx="8229600" cy="256032"/>
           </a:xfrm>
           <a:prstGeom prst="rect">
@@ -20054,13 +20878,13 @@
       </p:sp>
       <p:sp>
         <p:nvSpPr>
-          <p:cNvPr id="7" name="Text 5"/>
-          <p:cNvSpPr/>
-          <p:nvPr/>
-        </p:nvSpPr>
-        <p:spPr>
-          <a:xfrm>
-            <a:off x="640080" y="4619752"/>
+          <p:cNvPr id="4" name="Text 5"/>
+          <p:cNvSpPr/>
+          <p:nvPr/>
+        </p:nvSpPr>
+        <p:spPr>
+          <a:xfrm>
+            <a:off x="640080" y="4243300"/>
             <a:ext cx="9144000" cy="201168"/>
           </a:xfrm>
           <a:prstGeom prst="rect">
@@ -20093,13 +20917,13 @@
       </p:sp>
       <p:sp>
         <p:nvSpPr>
-          <p:cNvPr id="8" name="Text 6"/>
-          <p:cNvSpPr/>
-          <p:nvPr/>
-        </p:nvSpPr>
-        <p:spPr>
-          <a:xfrm>
-            <a:off x="640080" y="4820920"/>
+          <p:cNvPr id="9" name="Text 6"/>
+          <p:cNvSpPr/>
+          <p:nvPr/>
+        </p:nvSpPr>
+        <p:spPr>
+          <a:xfrm>
+            <a:off x="640080" y="4426180"/>
             <a:ext cx="8229600" cy="256032"/>
           </a:xfrm>
           <a:prstGeom prst="rect">
@@ -20124,7 +20948,7 @@
                 <a:ea typeface="Calibri" pitchFamily="34" charset="-122"/>
                 <a:cs typeface="Calibri" pitchFamily="34" charset="-120"/>
               </a:rPr>
-              <a:t>github.com/quinrobinson/AI-x-UX-Product-Design-Framework</a:t>
+              <a:t>github.com/quinrobinson/Agentic-Product-Design-Framework</a:t>
             </a:r>
             <a:endParaRPr lang="en-US" sz="1300" dirty="0"/>
           </a:p>
@@ -20166,42 +20990,6 @@
               <a:t>v1.0 — MIT License</a:t>
             </a:r>
             <a:endParaRPr lang="en-US" sz="900" dirty="0"/>
-          </a:p>
-        </p:txBody>
-      </p:sp>
-      <p:sp>
-        <p:nvSpPr>
-          <p:cNvPr id="17" name="Shape 11">
-            <a:extLst>
-              <a:ext uri="{FF2B5EF4-FFF2-40B4-BE49-F238E27FC236}">
-                <a16:creationId xmlns:a16="http://schemas.microsoft.com/office/drawing/2014/main" id="{0340DEBC-8F2B-D727-9DA9-F5D4C16F4F31}"/>
-              </a:ext>
-            </a:extLst>
-          </p:cNvPr>
-          <p:cNvSpPr/>
-          <p:nvPr/>
-        </p:nvSpPr>
-        <p:spPr>
-          <a:xfrm>
-            <a:off x="640080" y="5577840"/>
-            <a:ext cx="10881360" cy="0"/>
-          </a:xfrm>
-          <a:prstGeom prst="line">
-            <a:avLst/>
-          </a:prstGeom>
-          <a:noFill/>
-          <a:ln w="6350">
-            <a:solidFill>
-              <a:srgbClr val="334155"/>
-            </a:solidFill>
-            <a:prstDash val="solid"/>
-          </a:ln>
-        </p:spPr>
-        <p:txBody>
-          <a:bodyPr/>
-          <a:lstStyle/>
-          <a:p>
-            <a:endParaRPr lang="en-US"/>
           </a:p>
         </p:txBody>
       </p:sp>
@@ -20219,7 +21007,7 @@
         </p:nvSpPr>
         <p:spPr>
           <a:xfrm>
-            <a:off x="640080" y="5669280"/>
+            <a:off x="640080" y="5829921"/>
             <a:ext cx="1828800" cy="256032"/>
           </a:xfrm>
           <a:prstGeom prst="rect">
@@ -20275,7 +21063,7 @@
         </p:nvSpPr>
         <p:spPr>
           <a:xfrm>
-            <a:off x="640080" y="5943599"/>
+            <a:off x="640080" y="6104240"/>
             <a:ext cx="1280160" cy="0"/>
           </a:xfrm>
           <a:prstGeom prst="rect">
@@ -20317,7 +21105,7 @@
         </p:nvSpPr>
         <p:spPr>
           <a:xfrm>
-            <a:off x="2560320" y="5669280"/>
+            <a:off x="2560320" y="5829921"/>
             <a:ext cx="1828800" cy="256032"/>
           </a:xfrm>
           <a:prstGeom prst="rect">
@@ -20373,7 +21161,7 @@
         </p:nvSpPr>
         <p:spPr>
           <a:xfrm>
-            <a:off x="2560320" y="5943599"/>
+            <a:off x="2560320" y="6104240"/>
             <a:ext cx="1280160" cy="0"/>
           </a:xfrm>
           <a:prstGeom prst="rect">
@@ -20415,7 +21203,7 @@
         </p:nvSpPr>
         <p:spPr>
           <a:xfrm>
-            <a:off x="4480560" y="5669280"/>
+            <a:off x="4480560" y="5829921"/>
             <a:ext cx="1828800" cy="256032"/>
           </a:xfrm>
           <a:prstGeom prst="rect">
@@ -20471,7 +21259,7 @@
         </p:nvSpPr>
         <p:spPr>
           <a:xfrm>
-            <a:off x="4480560" y="5943599"/>
+            <a:off x="4480560" y="6104240"/>
             <a:ext cx="1280160" cy="0"/>
           </a:xfrm>
           <a:prstGeom prst="rect">
@@ -20513,7 +21301,7 @@
         </p:nvSpPr>
         <p:spPr>
           <a:xfrm>
-            <a:off x="6400800" y="5669280"/>
+            <a:off x="6400800" y="5829921"/>
             <a:ext cx="1828800" cy="256032"/>
           </a:xfrm>
           <a:prstGeom prst="rect">
@@ -20569,7 +21357,7 @@
         </p:nvSpPr>
         <p:spPr>
           <a:xfrm>
-            <a:off x="6400800" y="5943599"/>
+            <a:off x="6400800" y="6104240"/>
             <a:ext cx="1280160" cy="0"/>
           </a:xfrm>
           <a:prstGeom prst="rect">
@@ -20611,7 +21399,7 @@
         </p:nvSpPr>
         <p:spPr>
           <a:xfrm>
-            <a:off x="8321040" y="5669280"/>
+            <a:off x="8321040" y="5829921"/>
             <a:ext cx="1828800" cy="256032"/>
           </a:xfrm>
           <a:prstGeom prst="rect">
@@ -20667,7 +21455,7 @@
         </p:nvSpPr>
         <p:spPr>
           <a:xfrm>
-            <a:off x="8321040" y="5943599"/>
+            <a:off x="8321040" y="6104240"/>
             <a:ext cx="1280160" cy="0"/>
           </a:xfrm>
           <a:prstGeom prst="rect">
@@ -20709,7 +21497,7 @@
         </p:nvSpPr>
         <p:spPr>
           <a:xfrm>
-            <a:off x="10241280" y="5669280"/>
+            <a:off x="10241280" y="5829921"/>
             <a:ext cx="1828800" cy="256032"/>
           </a:xfrm>
           <a:prstGeom prst="rect">
@@ -20765,7 +21553,7 @@
         </p:nvSpPr>
         <p:spPr>
           <a:xfrm>
-            <a:off x="10241280" y="5943599"/>
+            <a:off x="10241280" y="6104240"/>
             <a:ext cx="1280160" cy="0"/>
           </a:xfrm>
           <a:prstGeom prst="rect">

</xml_diff>